<commit_message>
Expand decks to 15 slides and add the deliverable template workbooks
- Every deck now carries 15 slides: adds 想定問答 (3 likely questions with
  answers), 今日の用語 (3 terms) and 次回まで (next theme, homework, what to
  bring). Speaker notes written for all 15.
- New templates/: 成果物テンプレート.xlsx (12 sheets, worked example, live
  formulas) and 成果物テンプレート集_文書編.docx/pdf (17 pages, 6 document
  deliverables incl. two A4 handouts).
- slides.html: 12枚 -> 15枚 throughout, new section linking the templates.
- Stop tracking the desktop app's "Claude outputs" folder.

Co-Authored-By: Claude Opus 5 <noreply@anthropic.com>
Claude-Session: https://claude.ai/code/session_01BnqgQK1cdpwnR7CaS1h7Tu
</commit_message>
<xml_diff>
--- a/slides/pptx/第01回_現状把握と地図づくり.pptx
+++ b/slides/pptx/第01回_現状把握と地図づくり.pptx
@@ -17,9 +17,12 @@
     <p:sldId id="265" r:id="rId11"/>
     <p:sldId id="266" r:id="rId12"/>
     <p:sldId id="267" r:id="rId13"/>
+    <p:sldId id="268" r:id="rId14"/>
+    <p:sldId id="269" r:id="rId15"/>
+    <p:sldId id="270" r:id="rId16"/>
   </p:sldIdLst>
   <p:notesMasterIdLst>
-    <p:notesMasterId r:id="rId14"/>
+    <p:notesMasterId r:id="rId17"/>
   </p:notesMasterIdLst>
   <p:sldSz cx="12192000" cy="6858000"/>
   <p:notesSz cx="6858000" cy="12192000"/>
@@ -601,7 +604,7 @@
           <a:p>
             <a:r>
               <a:rPr lang="en-US" dirty="0"/>
-              <a:t>「いつ使うか」は必ず日時まで落とす。『来週あたり』は使われない。その場でカレンダーに入れてもらう。</a:t>
+              <a:t>用語を覚えてもらう必要はない。配布する用語辞典に同じものが載っていることを伝えるだけでよい。ハルシネーションだけは、この回で必ず言葉にしておく。</a:t>
             </a:r>
             <a:endParaRPr lang="en-US" dirty="0"/>
           </a:p>
@@ -689,7 +692,7 @@
           <a:p>
             <a:r>
               <a:rPr lang="en-US" dirty="0"/>
-              <a:t>ここは資料を読まない。事例だけ話す。初回の手応えが2回目の出席を決める、という構造を講師が理解していれば、自然に時間配分が変わる。</a:t>
+              <a:t>ここから講師は口頭指示のみ。画面を操作するのは必ず受講者。棚卸しは6列すべて埋めようとせず、上位3つだけ完成させればよい。</a:t>
             </a:r>
             <a:endParaRPr lang="en-US" dirty="0"/>
           </a:p>
@@ -777,7 +780,7 @@
           <a:p>
             <a:r>
               <a:rPr lang="en-US" dirty="0"/>
-              <a:t>宿題は口頭で確認して終わらせない。その場でスマホのカレンダーに入れてもらうところまでやる。次回の冒頭15分は、この宿題の実物から始まる。</a:t>
+              <a:t>「いつ使うか」は必ず日時まで落とす。『来週あたり』は使われない。その場でカレンダーに入れてもらう。</a:t>
             </a:r>
             <a:endParaRPr lang="en-US" dirty="0"/>
           </a:p>
@@ -801,6 +804,270 @@
             <a:fld id="{F7021451-1387-4CA6-816F-3879F97B5CBC}" type="slidenum">
               <a:rPr lang="en-US"/>
               <a:t>12</a:t>
+            </a:fld>
+            <a:endParaRPr lang="en-US"/>
+          </a:p>
+        </p:txBody>
+      </p:sp>
+    </p:spTree>
+    <p:extLst>
+      <p:ext uri="{BB962C8B-B14F-4D97-AF65-F5344CB8AC3E}">
+        <p14:creationId xmlns:p14="http://schemas.microsoft.com/office/powerpoint/2010/main" val="1024086991"/>
+      </p:ext>
+    </p:extLst>
+  </p:cSld>
+  <p:clrMapOvr>
+    <a:masterClrMapping/>
+  </p:clrMapOvr>
+</p:notes>
+</file>
+
+<file path=ppt/notesSlides/notesSlide13.xml><?xml version="1.0" encoding="utf-8"?>
+<p:notes xmlns:a="http://schemas.openxmlformats.org/drawingml/2006/main" xmlns:r="http://schemas.openxmlformats.org/officeDocument/2006/relationships" xmlns:p="http://schemas.openxmlformats.org/presentationml/2006/main">
+  <p:cSld>
+    <p:spTree>
+      <p:nvGrpSpPr>
+        <p:cNvPr id="1" name=""/>
+        <p:cNvGrpSpPr/>
+        <p:nvPr/>
+      </p:nvGrpSpPr>
+      <p:grpSpPr>
+        <a:xfrm>
+          <a:off x="0" y="0"/>
+          <a:ext cx="0" cy="0"/>
+          <a:chOff x="0" y="0"/>
+          <a:chExt cx="0" cy="0"/>
+        </a:xfrm>
+      </p:grpSpPr>
+      <p:sp>
+        <p:nvSpPr>
+          <p:cNvPr id="2" name="Slide Image Placeholder 1"/>
+          <p:cNvSpPr>
+            <a:spLocks noGrp="1" noRot="1" noChangeAspect="1"/>
+          </p:cNvSpPr>
+          <p:nvPr>
+            <p:ph type="sldImg"/>
+          </p:nvPr>
+        </p:nvSpPr>
+        <p:spPr/>
+      </p:sp>
+      <p:sp>
+        <p:nvSpPr>
+          <p:cNvPr id="3" name="Notes Placeholder 2"/>
+          <p:cNvSpPr>
+            <a:spLocks noGrp="1"/>
+          </p:cNvSpPr>
+          <p:nvPr>
+            <p:ph type="body" idx="1"/>
+          </p:nvPr>
+        </p:nvSpPr>
+        <p:spPr/>
+        <p:txBody>
+          <a:bodyPr/>
+          <a:lstStyle/>
+          <a:p>
+            <a:r>
+              <a:rPr lang="en-US" dirty="0"/>
+              <a:t>ここは資料を読まない。事例だけ話す。初回の手応えが2回目の出席を決める、という構造を講師が理解していれば、自然に時間配分が変わる。</a:t>
+            </a:r>
+            <a:endParaRPr lang="en-US" dirty="0"/>
+          </a:p>
+        </p:txBody>
+      </p:sp>
+      <p:sp>
+        <p:nvSpPr>
+          <p:cNvPr id="4" name="Slide Number Placeholder 3"/>
+          <p:cNvSpPr>
+            <a:spLocks noGrp="1"/>
+          </p:cNvSpPr>
+          <p:nvPr>
+            <p:ph type="sldNum" sz="quarter" idx="10"/>
+          </p:nvPr>
+        </p:nvSpPr>
+        <p:spPr/>
+        <p:txBody>
+          <a:bodyPr/>
+          <a:lstStyle/>
+          <a:p>
+            <a:fld id="{F7021451-1387-4CA6-816F-3879F97B5CBC}" type="slidenum">
+              <a:rPr lang="en-US"/>
+              <a:t>13</a:t>
+            </a:fld>
+            <a:endParaRPr lang="en-US"/>
+          </a:p>
+        </p:txBody>
+      </p:sp>
+    </p:spTree>
+    <p:extLst>
+      <p:ext uri="{BB962C8B-B14F-4D97-AF65-F5344CB8AC3E}">
+        <p14:creationId xmlns:p14="http://schemas.microsoft.com/office/powerpoint/2010/main" val="1024086991"/>
+      </p:ext>
+    </p:extLst>
+  </p:cSld>
+  <p:clrMapOvr>
+    <a:masterClrMapping/>
+  </p:clrMapOvr>
+</p:notes>
+</file>
+
+<file path=ppt/notesSlides/notesSlide14.xml><?xml version="1.0" encoding="utf-8"?>
+<p:notes xmlns:a="http://schemas.openxmlformats.org/drawingml/2006/main" xmlns:r="http://schemas.openxmlformats.org/officeDocument/2006/relationships" xmlns:p="http://schemas.openxmlformats.org/presentationml/2006/main">
+  <p:cSld>
+    <p:spTree>
+      <p:nvGrpSpPr>
+        <p:cNvPr id="1" name=""/>
+        <p:cNvGrpSpPr/>
+        <p:nvPr/>
+      </p:nvGrpSpPr>
+      <p:grpSpPr>
+        <a:xfrm>
+          <a:off x="0" y="0"/>
+          <a:ext cx="0" cy="0"/>
+          <a:chOff x="0" y="0"/>
+          <a:chExt cx="0" cy="0"/>
+        </a:xfrm>
+      </p:grpSpPr>
+      <p:sp>
+        <p:nvSpPr>
+          <p:cNvPr id="2" name="Slide Image Placeholder 1"/>
+          <p:cNvSpPr>
+            <a:spLocks noGrp="1" noRot="1" noChangeAspect="1"/>
+          </p:cNvSpPr>
+          <p:nvPr>
+            <p:ph type="sldImg"/>
+          </p:nvPr>
+        </p:nvSpPr>
+        <p:spPr/>
+      </p:sp>
+      <p:sp>
+        <p:nvSpPr>
+          <p:cNvPr id="3" name="Notes Placeholder 2"/>
+          <p:cNvSpPr>
+            <a:spLocks noGrp="1"/>
+          </p:cNvSpPr>
+          <p:nvPr>
+            <p:ph type="body" idx="1"/>
+          </p:nvPr>
+        </p:nvSpPr>
+        <p:spPr/>
+        <p:txBody>
+          <a:bodyPr/>
+          <a:lstStyle/>
+          <a:p>
+            <a:r>
+              <a:rPr lang="en-US" dirty="0"/>
+              <a:t>次回の持ち物を、口頭とチャットの両方で伝える。3日前にもう一度送る運用を、ここで予告しておく。</a:t>
+            </a:r>
+            <a:endParaRPr lang="en-US" dirty="0"/>
+          </a:p>
+        </p:txBody>
+      </p:sp>
+      <p:sp>
+        <p:nvSpPr>
+          <p:cNvPr id="4" name="Slide Number Placeholder 3"/>
+          <p:cNvSpPr>
+            <a:spLocks noGrp="1"/>
+          </p:cNvSpPr>
+          <p:nvPr>
+            <p:ph type="sldNum" sz="quarter" idx="10"/>
+          </p:nvPr>
+        </p:nvSpPr>
+        <p:spPr/>
+        <p:txBody>
+          <a:bodyPr/>
+          <a:lstStyle/>
+          <a:p>
+            <a:fld id="{F7021451-1387-4CA6-816F-3879F97B5CBC}" type="slidenum">
+              <a:rPr lang="en-US"/>
+              <a:t>14</a:t>
+            </a:fld>
+            <a:endParaRPr lang="en-US"/>
+          </a:p>
+        </p:txBody>
+      </p:sp>
+    </p:spTree>
+    <p:extLst>
+      <p:ext uri="{BB962C8B-B14F-4D97-AF65-F5344CB8AC3E}">
+        <p14:creationId xmlns:p14="http://schemas.microsoft.com/office/powerpoint/2010/main" val="1024086991"/>
+      </p:ext>
+    </p:extLst>
+  </p:cSld>
+  <p:clrMapOvr>
+    <a:masterClrMapping/>
+  </p:clrMapOvr>
+</p:notes>
+</file>
+
+<file path=ppt/notesSlides/notesSlide15.xml><?xml version="1.0" encoding="utf-8"?>
+<p:notes xmlns:a="http://schemas.openxmlformats.org/drawingml/2006/main" xmlns:r="http://schemas.openxmlformats.org/officeDocument/2006/relationships" xmlns:p="http://schemas.openxmlformats.org/presentationml/2006/main">
+  <p:cSld>
+    <p:spTree>
+      <p:nvGrpSpPr>
+        <p:cNvPr id="1" name=""/>
+        <p:cNvGrpSpPr/>
+        <p:nvPr/>
+      </p:nvGrpSpPr>
+      <p:grpSpPr>
+        <a:xfrm>
+          <a:off x="0" y="0"/>
+          <a:ext cx="0" cy="0"/>
+          <a:chOff x="0" y="0"/>
+          <a:chExt cx="0" cy="0"/>
+        </a:xfrm>
+      </p:grpSpPr>
+      <p:sp>
+        <p:nvSpPr>
+          <p:cNvPr id="2" name="Slide Image Placeholder 1"/>
+          <p:cNvSpPr>
+            <a:spLocks noGrp="1" noRot="1" noChangeAspect="1"/>
+          </p:cNvSpPr>
+          <p:nvPr>
+            <p:ph type="sldImg"/>
+          </p:nvPr>
+        </p:nvSpPr>
+        <p:spPr/>
+      </p:sp>
+      <p:sp>
+        <p:nvSpPr>
+          <p:cNvPr id="3" name="Notes Placeholder 2"/>
+          <p:cNvSpPr>
+            <a:spLocks noGrp="1"/>
+          </p:cNvSpPr>
+          <p:nvPr>
+            <p:ph type="body" idx="1"/>
+          </p:nvPr>
+        </p:nvSpPr>
+        <p:spPr/>
+        <p:txBody>
+          <a:bodyPr/>
+          <a:lstStyle/>
+          <a:p>
+            <a:r>
+              <a:rPr lang="en-US" dirty="0"/>
+              <a:t>宿題は口頭で確認して終わらせない。その場でスマホのカレンダーに入れてもらうところまでやる。次回の冒頭15分は、この宿題の実物から始まる。</a:t>
+            </a:r>
+            <a:endParaRPr lang="en-US" dirty="0"/>
+          </a:p>
+        </p:txBody>
+      </p:sp>
+      <p:sp>
+        <p:nvSpPr>
+          <p:cNvPr id="4" name="Slide Number Placeholder 3"/>
+          <p:cNvSpPr>
+            <a:spLocks noGrp="1"/>
+          </p:cNvSpPr>
+          <p:nvPr>
+            <p:ph type="sldNum" sz="quarter" idx="10"/>
+          </p:nvPr>
+        </p:nvSpPr>
+        <p:spPr/>
+        <p:txBody>
+          <a:bodyPr/>
+          <a:lstStyle/>
+          <a:p>
+            <a:fld id="{F7021451-1387-4CA6-816F-3879F97B5CBC}" type="slidenum">
+              <a:rPr lang="en-US"/>
+              <a:t>15</a:t>
             </a:fld>
             <a:endParaRPr lang="en-US"/>
           </a:p>
@@ -1481,7 +1748,7 @@
           <a:p>
             <a:r>
               <a:rPr lang="en-US" dirty="0"/>
-              <a:t>ここから講師は口頭指示のみ。画面を操作するのは必ず受講者。棚卸しは6列すべて埋めようとせず、上位3つだけ完成させればよい。</a:t>
+              <a:t>3つとも初回で高確率で出る。特に2つ目は、ここで押し切らないと講座全体が空回りする。『判断の勘所は使った人にしか分からない』を、経営者本人の経験に引き寄せて話す。</a:t>
             </a:r>
             <a:endParaRPr lang="en-US" dirty="0"/>
           </a:p>
@@ -2175,13 +2442,13 @@
             <a:r>
               <a:rPr lang="en-US" sz="1100" b="1" spc="250" kern="0" dirty="0">
                 <a:solidFill>
-                  <a:srgbClr val="3B6B4A"/>
-                </a:solidFill>
-                <a:latin typeface="Yu Gothic" pitchFamily="34" charset="0"/>
-                <a:ea typeface="Yu Gothic" pitchFamily="34" charset="-122"/>
-                <a:cs typeface="Yu Gothic" pitchFamily="34" charset="-120"/>
-              </a:rPr>
-              <a:t>業務への組み込み</a:t>
+                  <a:srgbClr val="8A8177"/>
+                </a:solidFill>
+                <a:latin typeface="Yu Gothic" pitchFamily="34" charset="0"/>
+                <a:ea typeface="Yu Gothic" pitchFamily="34" charset="-122"/>
+                <a:cs typeface="Yu Gothic" pitchFamily="34" charset="-120"/>
+              </a:rPr>
+              <a:t>用語</a:t>
             </a:r>
             <a:endParaRPr lang="en-US" sz="1100" dirty="0"/>
           </a:p>
@@ -2220,7 +2487,7 @@
                 <a:ea typeface="Yu Gothic" pitchFamily="34" charset="-122"/>
                 <a:cs typeface="Yu Gothic" pitchFamily="34" charset="-120"/>
               </a:rPr>
-              <a:t>帰る前に決めること</a:t>
+              <a:t>今日出てきた言葉</a:t>
             </a:r>
             <a:endParaRPr lang="en-US" sz="2600" dirty="0"/>
           </a:p>
@@ -2228,53 +2495,14 @@
       </p:sp>
       <p:sp>
         <p:nvSpPr>
-          <p:cNvPr id="4" name="Text 2"/>
-          <p:cNvSpPr txBox="1"/>
-          <p:nvPr/>
-        </p:nvSpPr>
-        <p:spPr>
-          <a:xfrm>
-            <a:off x="777240" y="1572768"/>
-            <a:ext cx="10607040" cy="320040"/>
-          </a:xfrm>
-          <a:prstGeom prst="rect">
-            <a:avLst/>
-          </a:prstGeom>
-          <a:noFill/>
-          <a:ln/>
-        </p:spPr>
-        <p:txBody>
-          <a:bodyPr wrap="square" lIns="0" tIns="0" rIns="0" bIns="0" rtlCol="0" anchor="ctr"/>
-          <a:lstStyle/>
-          <a:p>
-            <a:pPr indent="0" marL="0">
-              <a:buNone/>
-            </a:pPr>
-            <a:r>
-              <a:rPr lang="en-US" sz="1250" b="1" dirty="0">
-                <a:solidFill>
-                  <a:srgbClr val="3B6B4A"/>
-                </a:solidFill>
-                <a:latin typeface="Yu Gothic" pitchFamily="34" charset="0"/>
-                <a:ea typeface="Yu Gothic" pitchFamily="34" charset="-122"/>
-                <a:cs typeface="Yu Gothic" pitchFamily="34" charset="-120"/>
-              </a:rPr>
-              <a:t>ここを決めないと、持ち帰っても使われません。紙に書きます。</a:t>
-            </a:r>
-            <a:endParaRPr lang="en-US" sz="1250" dirty="0"/>
-          </a:p>
-        </p:txBody>
-      </p:sp>
-      <p:sp>
-        <p:nvSpPr>
-          <p:cNvPr id="5" name="Shape 3"/>
+          <p:cNvPr id="4" name="Shape 2"/>
           <p:cNvSpPr/>
           <p:nvPr/>
         </p:nvSpPr>
         <p:spPr>
           <a:xfrm>
-            <a:off x="777240" y="2103120"/>
-            <a:ext cx="10607040" cy="914400"/>
+            <a:off x="777240" y="1828800"/>
+            <a:ext cx="10607040" cy="1078992"/>
           </a:xfrm>
           <a:prstGeom prst="rect">
             <a:avLst/>
@@ -2292,20 +2520,59 @@
       </p:sp>
       <p:sp>
         <p:nvSpPr>
+          <p:cNvPr id="5" name="Text 3"/>
+          <p:cNvSpPr txBox="1"/>
+          <p:nvPr/>
+        </p:nvSpPr>
+        <p:spPr>
+          <a:xfrm>
+            <a:off x="1097280" y="1920240"/>
+            <a:ext cx="2969971" cy="896112"/>
+          </a:xfrm>
+          <a:prstGeom prst="rect">
+            <a:avLst/>
+          </a:prstGeom>
+          <a:noFill/>
+          <a:ln/>
+        </p:spPr>
+        <p:txBody>
+          <a:bodyPr wrap="square" lIns="0" tIns="0" rIns="0" bIns="0" rtlCol="0" anchor="ctr"/>
+          <a:lstStyle/>
+          <a:p>
+            <a:pPr indent="0" marL="0">
+              <a:buNone/>
+            </a:pPr>
+            <a:r>
+              <a:rPr lang="en-US" sz="1500" b="1" dirty="0">
+                <a:solidFill>
+                  <a:srgbClr val="23201D"/>
+                </a:solidFill>
+                <a:latin typeface="Yu Gothic" pitchFamily="34" charset="0"/>
+                <a:ea typeface="Yu Gothic" pitchFamily="34" charset="-122"/>
+                <a:cs typeface="Yu Gothic" pitchFamily="34" charset="-120"/>
+              </a:rPr>
+              <a:t>プロンプト</a:t>
+            </a:r>
+            <a:endParaRPr lang="en-US" sz="1500" dirty="0"/>
+          </a:p>
+        </p:txBody>
+      </p:sp>
+      <p:sp>
+        <p:nvSpPr>
           <p:cNvPr id="6" name="Shape 4"/>
           <p:cNvSpPr/>
           <p:nvPr/>
         </p:nvSpPr>
         <p:spPr>
           <a:xfrm>
-            <a:off x="777240" y="2103120"/>
-            <a:ext cx="54864" cy="914400"/>
+            <a:off x="4065422" y="1956816"/>
+            <a:ext cx="18288" cy="822960"/>
           </a:xfrm>
           <a:prstGeom prst="rect">
             <a:avLst/>
           </a:prstGeom>
           <a:solidFill>
-            <a:srgbClr val="3B6B4A"/>
+            <a:srgbClr val="EDE7DB"/>
           </a:solidFill>
           <a:ln w="12700">
             <a:solidFill>
@@ -2323,47 +2590,8 @@
         </p:nvSpPr>
         <p:spPr>
           <a:xfrm>
-            <a:off x="1143000" y="2176272"/>
-            <a:ext cx="2757830" cy="768096"/>
-          </a:xfrm>
-          <a:prstGeom prst="rect">
-            <a:avLst/>
-          </a:prstGeom>
-          <a:noFill/>
-          <a:ln/>
-        </p:spPr>
-        <p:txBody>
-          <a:bodyPr wrap="square" lIns="0" tIns="0" rIns="0" bIns="0" rtlCol="0" anchor="ctr"/>
-          <a:lstStyle/>
-          <a:p>
-            <a:pPr indent="0" marL="0">
-              <a:buNone/>
-            </a:pPr>
-            <a:r>
-              <a:rPr lang="en-US" sz="1400" b="1" dirty="0">
-                <a:solidFill>
-                  <a:srgbClr val="3B6B4A"/>
-                </a:solidFill>
-                <a:latin typeface="Yu Gothic" pitchFamily="34" charset="0"/>
-                <a:ea typeface="Yu Gothic" pitchFamily="34" charset="-122"/>
-                <a:cs typeface="Yu Gothic" pitchFamily="34" charset="-120"/>
-              </a:rPr>
-              <a:t>いつ使うか</a:t>
-            </a:r>
-            <a:endParaRPr lang="en-US" sz="1400" dirty="0"/>
-          </a:p>
-        </p:txBody>
-      </p:sp>
-      <p:sp>
-        <p:nvSpPr>
-          <p:cNvPr id="8" name="Text 6"/>
-          <p:cNvSpPr txBox="1"/>
-          <p:nvPr/>
-        </p:nvSpPr>
-        <p:spPr>
-          <a:xfrm>
-            <a:off x="4006901" y="2176272"/>
-            <a:ext cx="7011619" cy="768096"/>
+            <a:off x="4383634" y="1920240"/>
+            <a:ext cx="6682435" cy="896112"/>
           </a:xfrm>
           <a:prstGeom prst="rect">
             <a:avLst/>
@@ -2384,13 +2612,13 @@
             <a:r>
               <a:rPr lang="en-US" sz="1250" dirty="0">
                 <a:solidFill>
-                  <a:srgbClr val="3F3933"/>
-                </a:solidFill>
-                <a:latin typeface="Yu Gothic" pitchFamily="34" charset="0"/>
-                <a:ea typeface="Yu Gothic" pitchFamily="34" charset="-122"/>
-                <a:cs typeface="Yu Gothic" pitchFamily="34" charset="-120"/>
-              </a:rPr>
-              <a:t>「明日の朝いち、見積を書く前に」まで具体的に決めます</a:t>
+                  <a:srgbClr val="5A534A"/>
+                </a:solidFill>
+                <a:latin typeface="Yu Gothic" pitchFamily="34" charset="0"/>
+                <a:ea typeface="Yu Gothic" pitchFamily="34" charset="-122"/>
+                <a:cs typeface="Yu Gothic" pitchFamily="34" charset="-120"/>
+              </a:rPr>
+              <a:t>AIへの指示文。長さより、前提と条件が入っているかが効きます</a:t>
             </a:r>
             <a:endParaRPr lang="en-US" sz="1250" dirty="0"/>
           </a:p>
@@ -2398,14 +2626,14 @@
       </p:sp>
       <p:sp>
         <p:nvSpPr>
-          <p:cNvPr id="9" name="Shape 7"/>
+          <p:cNvPr id="8" name="Shape 6"/>
           <p:cNvSpPr/>
           <p:nvPr/>
         </p:nvSpPr>
         <p:spPr>
           <a:xfrm>
-            <a:off x="777240" y="3154680"/>
-            <a:ext cx="10607040" cy="914400"/>
+            <a:off x="777240" y="3063240"/>
+            <a:ext cx="10607040" cy="1078992"/>
           </a:xfrm>
           <a:prstGeom prst="rect">
             <a:avLst/>
@@ -2423,20 +2651,59 @@
       </p:sp>
       <p:sp>
         <p:nvSpPr>
+          <p:cNvPr id="9" name="Text 7"/>
+          <p:cNvSpPr txBox="1"/>
+          <p:nvPr/>
+        </p:nvSpPr>
+        <p:spPr>
+          <a:xfrm>
+            <a:off x="1097280" y="3154680"/>
+            <a:ext cx="2969971" cy="896112"/>
+          </a:xfrm>
+          <a:prstGeom prst="rect">
+            <a:avLst/>
+          </a:prstGeom>
+          <a:noFill/>
+          <a:ln/>
+        </p:spPr>
+        <p:txBody>
+          <a:bodyPr wrap="square" lIns="0" tIns="0" rIns="0" bIns="0" rtlCol="0" anchor="ctr"/>
+          <a:lstStyle/>
+          <a:p>
+            <a:pPr indent="0" marL="0">
+              <a:buNone/>
+            </a:pPr>
+            <a:r>
+              <a:rPr lang="en-US" sz="1500" b="1" dirty="0">
+                <a:solidFill>
+                  <a:srgbClr val="23201D"/>
+                </a:solidFill>
+                <a:latin typeface="Yu Gothic" pitchFamily="34" charset="0"/>
+                <a:ea typeface="Yu Gothic" pitchFamily="34" charset="-122"/>
+                <a:cs typeface="Yu Gothic" pitchFamily="34" charset="-120"/>
+              </a:rPr>
+              <a:t>ハルシネーション</a:t>
+            </a:r>
+            <a:endParaRPr lang="en-US" sz="1500" dirty="0"/>
+          </a:p>
+        </p:txBody>
+      </p:sp>
+      <p:sp>
+        <p:nvSpPr>
           <p:cNvPr id="10" name="Shape 8"/>
           <p:cNvSpPr/>
           <p:nvPr/>
         </p:nvSpPr>
         <p:spPr>
           <a:xfrm>
-            <a:off x="777240" y="3154680"/>
-            <a:ext cx="54864" cy="914400"/>
+            <a:off x="4065422" y="3191256"/>
+            <a:ext cx="18288" cy="822960"/>
           </a:xfrm>
           <a:prstGeom prst="rect">
             <a:avLst/>
           </a:prstGeom>
           <a:solidFill>
-            <a:srgbClr val="3B6B4A"/>
+            <a:srgbClr val="EDE7DB"/>
           </a:solidFill>
           <a:ln w="12700">
             <a:solidFill>
@@ -2454,47 +2721,8 @@
         </p:nvSpPr>
         <p:spPr>
           <a:xfrm>
-            <a:off x="1143000" y="3227832"/>
-            <a:ext cx="2757830" cy="768096"/>
-          </a:xfrm>
-          <a:prstGeom prst="rect">
-            <a:avLst/>
-          </a:prstGeom>
-          <a:noFill/>
-          <a:ln/>
-        </p:spPr>
-        <p:txBody>
-          <a:bodyPr wrap="square" lIns="0" tIns="0" rIns="0" bIns="0" rtlCol="0" anchor="ctr"/>
-          <a:lstStyle/>
-          <a:p>
-            <a:pPr indent="0" marL="0">
-              <a:buNone/>
-            </a:pPr>
-            <a:r>
-              <a:rPr lang="en-US" sz="1400" b="1" dirty="0">
-                <a:solidFill>
-                  <a:srgbClr val="3B6B4A"/>
-                </a:solidFill>
-                <a:latin typeface="Yu Gothic" pitchFamily="34" charset="0"/>
-                <a:ea typeface="Yu Gothic" pitchFamily="34" charset="-122"/>
-                <a:cs typeface="Yu Gothic" pitchFamily="34" charset="-120"/>
-              </a:rPr>
-              <a:t>誰が使うか</a:t>
-            </a:r>
-            <a:endParaRPr lang="en-US" sz="1400" dirty="0"/>
-          </a:p>
-        </p:txBody>
-      </p:sp>
-      <p:sp>
-        <p:nvSpPr>
-          <p:cNvPr id="12" name="Text 10"/>
-          <p:cNvSpPr txBox="1"/>
-          <p:nvPr/>
-        </p:nvSpPr>
-        <p:spPr>
-          <a:xfrm>
-            <a:off x="4006901" y="3227832"/>
-            <a:ext cx="7011619" cy="768096"/>
+            <a:off x="4383634" y="3154680"/>
+            <a:ext cx="6682435" cy="896112"/>
           </a:xfrm>
           <a:prstGeom prst="rect">
             <a:avLst/>
@@ -2515,13 +2743,13 @@
             <a:r>
               <a:rPr lang="en-US" sz="1250" dirty="0">
                 <a:solidFill>
-                  <a:srgbClr val="3F3933"/>
-                </a:solidFill>
-                <a:latin typeface="Yu Gothic" pitchFamily="34" charset="0"/>
-                <a:ea typeface="Yu Gothic" pitchFamily="34" charset="-122"/>
-                <a:cs typeface="Yu Gothic" pitchFamily="34" charset="-120"/>
-              </a:rPr>
-              <a:t>当面は社長ご自身です。社員に渡すのは第3回から</a:t>
+                  <a:srgbClr val="5A534A"/>
+                </a:solidFill>
+                <a:latin typeface="Yu Gothic" pitchFamily="34" charset="0"/>
+                <a:ea typeface="Yu Gothic" pitchFamily="34" charset="-122"/>
+                <a:cs typeface="Yu Gothic" pitchFamily="34" charset="-120"/>
+              </a:rPr>
+              <a:t>AIがもっともらしい嘘を言うこと。無くなりません。前提として仕組みを作ります</a:t>
             </a:r>
             <a:endParaRPr lang="en-US" sz="1250" dirty="0"/>
           </a:p>
@@ -2529,14 +2757,14 @@
       </p:sp>
       <p:sp>
         <p:nvSpPr>
-          <p:cNvPr id="13" name="Shape 11"/>
+          <p:cNvPr id="12" name="Shape 10"/>
           <p:cNvSpPr/>
           <p:nvPr/>
         </p:nvSpPr>
         <p:spPr>
           <a:xfrm>
-            <a:off x="777240" y="4206240"/>
-            <a:ext cx="10607040" cy="914400"/>
+            <a:off x="777240" y="4297680"/>
+            <a:ext cx="10607040" cy="1078992"/>
           </a:xfrm>
           <a:prstGeom prst="rect">
             <a:avLst/>
@@ -2554,20 +2782,59 @@
       </p:sp>
       <p:sp>
         <p:nvSpPr>
+          <p:cNvPr id="13" name="Text 11"/>
+          <p:cNvSpPr txBox="1"/>
+          <p:nvPr/>
+        </p:nvSpPr>
+        <p:spPr>
+          <a:xfrm>
+            <a:off x="1097280" y="4389120"/>
+            <a:ext cx="2969971" cy="896112"/>
+          </a:xfrm>
+          <a:prstGeom prst="rect">
+            <a:avLst/>
+          </a:prstGeom>
+          <a:noFill/>
+          <a:ln/>
+        </p:spPr>
+        <p:txBody>
+          <a:bodyPr wrap="square" lIns="0" tIns="0" rIns="0" bIns="0" rtlCol="0" anchor="ctr"/>
+          <a:lstStyle/>
+          <a:p>
+            <a:pPr indent="0" marL="0">
+              <a:buNone/>
+            </a:pPr>
+            <a:r>
+              <a:rPr lang="en-US" sz="1500" b="1" dirty="0">
+                <a:solidFill>
+                  <a:srgbClr val="23201D"/>
+                </a:solidFill>
+                <a:latin typeface="Yu Gothic" pitchFamily="34" charset="0"/>
+                <a:ea typeface="Yu Gothic" pitchFamily="34" charset="-122"/>
+                <a:cs typeface="Yu Gothic" pitchFamily="34" charset="-120"/>
+              </a:rPr>
+              <a:t>棚卸し</a:t>
+            </a:r>
+            <a:endParaRPr lang="en-US" sz="1500" dirty="0"/>
+          </a:p>
+        </p:txBody>
+      </p:sp>
+      <p:sp>
+        <p:nvSpPr>
           <p:cNvPr id="14" name="Shape 12"/>
           <p:cNvSpPr/>
           <p:nvPr/>
         </p:nvSpPr>
         <p:spPr>
           <a:xfrm>
-            <a:off x="777240" y="4206240"/>
-            <a:ext cx="54864" cy="914400"/>
+            <a:off x="4065422" y="4425696"/>
+            <a:ext cx="18288" cy="822960"/>
           </a:xfrm>
           <a:prstGeom prst="rect">
             <a:avLst/>
           </a:prstGeom>
           <a:solidFill>
-            <a:srgbClr val="3B6B4A"/>
+            <a:srgbClr val="EDE7DB"/>
           </a:solidFill>
           <a:ln w="12700">
             <a:solidFill>
@@ -2585,47 +2852,8 @@
         </p:nvSpPr>
         <p:spPr>
           <a:xfrm>
-            <a:off x="1143000" y="4279392"/>
-            <a:ext cx="2757830" cy="768096"/>
-          </a:xfrm>
-          <a:prstGeom prst="rect">
-            <a:avLst/>
-          </a:prstGeom>
-          <a:noFill/>
-          <a:ln/>
-        </p:spPr>
-        <p:txBody>
-          <a:bodyPr wrap="square" lIns="0" tIns="0" rIns="0" bIns="0" rtlCol="0" anchor="ctr"/>
-          <a:lstStyle/>
-          <a:p>
-            <a:pPr indent="0" marL="0">
-              <a:buNone/>
-            </a:pPr>
-            <a:r>
-              <a:rPr lang="en-US" sz="1400" b="1" dirty="0">
-                <a:solidFill>
-                  <a:srgbClr val="3B6B4A"/>
-                </a:solidFill>
-                <a:latin typeface="Yu Gothic" pitchFamily="34" charset="0"/>
-                <a:ea typeface="Yu Gothic" pitchFamily="34" charset="-122"/>
-                <a:cs typeface="Yu Gothic" pitchFamily="34" charset="-120"/>
-              </a:rPr>
-              <a:t>何を確認するか</a:t>
-            </a:r>
-            <a:endParaRPr lang="en-US" sz="1400" dirty="0"/>
-          </a:p>
-        </p:txBody>
-      </p:sp>
-      <p:sp>
-        <p:nvSpPr>
-          <p:cNvPr id="16" name="Text 14"/>
-          <p:cNvSpPr txBox="1"/>
-          <p:nvPr/>
-        </p:nvSpPr>
-        <p:spPr>
-          <a:xfrm>
-            <a:off x="4006901" y="4279392"/>
-            <a:ext cx="7011619" cy="768096"/>
+            <a:off x="4383634" y="4389120"/>
+            <a:ext cx="6682435" cy="896112"/>
           </a:xfrm>
           <a:prstGeom prst="rect">
             <a:avLst/>
@@ -2646,15 +2874,54 @@
             <a:r>
               <a:rPr lang="en-US" sz="1250" dirty="0">
                 <a:solidFill>
-                  <a:srgbClr val="3F3933"/>
-                </a:solidFill>
-                <a:latin typeface="Yu Gothic" pitchFamily="34" charset="0"/>
-                <a:ea typeface="Yu Gothic" pitchFamily="34" charset="-122"/>
-                <a:cs typeface="Yu Gothic" pitchFamily="34" charset="-120"/>
-              </a:rPr>
-              <a:t>出てきた金額と数字は、提出前に必ず目視で確認します</a:t>
+                  <a:srgbClr val="5A534A"/>
+                </a:solidFill>
+                <a:latin typeface="Yu Gothic" pitchFamily="34" charset="0"/>
+                <a:ea typeface="Yu Gothic" pitchFamily="34" charset="-122"/>
+                <a:cs typeface="Yu Gothic" pitchFamily="34" charset="-120"/>
+              </a:rPr>
+              <a:t>業務を、誰が・どのくらいの頻度で・1回何分、に分解して並べること</a:t>
             </a:r>
             <a:endParaRPr lang="en-US" sz="1250" dirty="0"/>
+          </a:p>
+        </p:txBody>
+      </p:sp>
+      <p:sp>
+        <p:nvSpPr>
+          <p:cNvPr id="16" name="Text 14"/>
+          <p:cNvSpPr txBox="1"/>
+          <p:nvPr/>
+        </p:nvSpPr>
+        <p:spPr>
+          <a:xfrm>
+            <a:off x="777240" y="5623560"/>
+            <a:ext cx="10607040" cy="411480"/>
+          </a:xfrm>
+          <a:prstGeom prst="rect">
+            <a:avLst/>
+          </a:prstGeom>
+          <a:noFill/>
+          <a:ln/>
+        </p:spPr>
+        <p:txBody>
+          <a:bodyPr wrap="square" lIns="0" tIns="0" rIns="0" bIns="0" rtlCol="0" anchor="ctr"/>
+          <a:lstStyle/>
+          <a:p>
+            <a:pPr indent="0" marL="0">
+              <a:buNone/>
+            </a:pPr>
+            <a:r>
+              <a:rPr lang="en-US" sz="1150" dirty="0">
+                <a:solidFill>
+                  <a:srgbClr val="8A8177"/>
+                </a:solidFill>
+                <a:latin typeface="Yu Gothic" pitchFamily="34" charset="0"/>
+                <a:ea typeface="Yu Gothic" pitchFamily="34" charset="-122"/>
+                <a:cs typeface="Yu Gothic" pitchFamily="34" charset="-120"/>
+              </a:rPr>
+              <a:t>配布した用語辞典にも同じものが載っています。覚える必要はありません。</a:t>
+            </a:r>
+            <a:endParaRPr lang="en-US" sz="1150" dirty="0"/>
           </a:p>
         </p:txBody>
       </p:sp>
@@ -2730,7 +2997,7 @@
                 <a:ea typeface="Yu Gothic" pitchFamily="34" charset="-122"/>
                 <a:cs typeface="Yu Gothic" pitchFamily="34" charset="-120"/>
               </a:rPr>
-              <a:t>組み込み</a:t>
+              <a:t>用語</a:t>
             </a:r>
             <a:endParaRPr lang="en-US" sz="900" dirty="0"/>
           </a:p>
@@ -2795,13 +3062,13 @@
             <a:r>
               <a:rPr lang="en-US" sz="1100" b="1" spc="250" kern="0" dirty="0">
                 <a:solidFill>
-                  <a:srgbClr val="B04A2F"/>
-                </a:solidFill>
-                <a:latin typeface="Yu Gothic" pitchFamily="34" charset="0"/>
-                <a:ea typeface="Yu Gothic" pitchFamily="34" charset="-122"/>
-                <a:cs typeface="Yu Gothic" pitchFamily="34" charset="-120"/>
-              </a:rPr>
-              <a:t>ここだけは</a:t>
+                  <a:srgbClr val="2F4F6B"/>
+                </a:solidFill>
+                <a:latin typeface="Yu Gothic" pitchFamily="34" charset="0"/>
+                <a:ea typeface="Yu Gothic" pitchFamily="34" charset="-122"/>
+                <a:cs typeface="Yu Gothic" pitchFamily="34" charset="-120"/>
+              </a:rPr>
+              <a:t>演習</a:t>
             </a:r>
             <a:endParaRPr lang="en-US" sz="1100" dirty="0"/>
           </a:p>
@@ -2815,7 +3082,7 @@
         </p:nvSpPr>
         <p:spPr>
           <a:xfrm>
-            <a:off x="777240" y="1097280"/>
+            <a:off x="777240" y="896112"/>
             <a:ext cx="10607040" cy="640080"/>
           </a:xfrm>
           <a:prstGeom prst="rect">
@@ -2840,7 +3107,7 @@
                 <a:ea typeface="Yu Gothic" pitchFamily="34" charset="-122"/>
                 <a:cs typeface="Yu Gothic" pitchFamily="34" charset="-120"/>
               </a:rPr>
-              <a:t>今日は、成果より「手応え」を持ち帰る回です</a:t>
+              <a:t>今日、一緒にやること</a:t>
             </a:r>
             <a:endParaRPr lang="en-US" sz="2600" dirty="0"/>
           </a:p>
@@ -2848,20 +3115,84 @@
       </p:sp>
       <p:sp>
         <p:nvSpPr>
-          <p:cNvPr id="4" name="Shape 2"/>
+          <p:cNvPr id="4" name="Text 2"/>
+          <p:cNvSpPr txBox="1"/>
+          <p:nvPr/>
+        </p:nvSpPr>
+        <p:spPr>
+          <a:xfrm>
+            <a:off x="777240" y="1572768"/>
+            <a:ext cx="10607040" cy="320040"/>
+          </a:xfrm>
+          <a:prstGeom prst="rect">
+            <a:avLst/>
+          </a:prstGeom>
+          <a:noFill/>
+          <a:ln/>
+        </p:spPr>
+        <p:txBody>
+          <a:bodyPr wrap="square" lIns="0" tIns="0" rIns="0" bIns="0" rtlCol="0" anchor="ctr"/>
+          <a:lstStyle/>
+          <a:p>
+            <a:pPr indent="0" marL="0">
+              <a:buNone/>
+            </a:pPr>
+            <a:r>
+              <a:rPr lang="en-US" sz="1250" b="1" dirty="0">
+                <a:solidFill>
+                  <a:srgbClr val="2F4F6B"/>
+                </a:solidFill>
+                <a:latin typeface="Yu Gothic" pitchFamily="34" charset="0"/>
+                <a:ea typeface="Yu Gothic" pitchFamily="34" charset="-122"/>
+                <a:cs typeface="Yu Gothic" pitchFamily="34" charset="-120"/>
+              </a:rPr>
+              <a:t>55分。操作するのはご自身です。</a:t>
+            </a:r>
+            <a:endParaRPr lang="en-US" sz="1250" dirty="0"/>
+          </a:p>
+        </p:txBody>
+      </p:sp>
+      <p:sp>
+        <p:nvSpPr>
+          <p:cNvPr id="5" name="Shape 3"/>
           <p:cNvSpPr/>
           <p:nvPr/>
         </p:nvSpPr>
         <p:spPr>
           <a:xfrm>
             <a:off x="777240" y="2148840"/>
-            <a:ext cx="64008" cy="2194560"/>
+            <a:ext cx="3383280" cy="2880360"/>
           </a:xfrm>
           <a:prstGeom prst="rect">
             <a:avLst/>
           </a:prstGeom>
           <a:solidFill>
-            <a:srgbClr val="B04A2F"/>
+            <a:srgbClr val="FFFFFF"/>
+          </a:solidFill>
+          <a:ln w="12700">
+            <a:solidFill>
+              <a:srgbClr val="EDE7DB"/>
+            </a:solidFill>
+            <a:prstDash val="solid"/>
+          </a:ln>
+        </p:spPr>
+      </p:sp>
+      <p:sp>
+        <p:nvSpPr>
+          <p:cNvPr id="6" name="Shape 4"/>
+          <p:cNvSpPr/>
+          <p:nvPr/>
+        </p:nvSpPr>
+        <p:spPr>
+          <a:xfrm>
+            <a:off x="1051560" y="2395728"/>
+            <a:ext cx="438912" cy="438912"/>
+          </a:xfrm>
+          <a:prstGeom prst="ellipse">
+            <a:avLst/>
+          </a:prstGeom>
+          <a:solidFill>
+            <a:srgbClr val="2F4F6B"/>
           </a:solidFill>
           <a:ln w="12700">
             <a:solidFill>
@@ -2873,14 +3204,53 @@
       </p:sp>
       <p:sp>
         <p:nvSpPr>
-          <p:cNvPr id="5" name="Text 3"/>
-          <p:cNvSpPr txBox="1"/>
-          <p:nvPr/>
-        </p:nvSpPr>
-        <p:spPr>
-          <a:xfrm>
-            <a:off x="1188720" y="2148840"/>
-            <a:ext cx="9966960" cy="2194560"/>
+          <p:cNvPr id="7" name="Text 5"/>
+          <p:cNvSpPr txBox="1"/>
+          <p:nvPr/>
+        </p:nvSpPr>
+        <p:spPr>
+          <a:xfrm>
+            <a:off x="1051560" y="2395728"/>
+            <a:ext cx="438912" cy="438912"/>
+          </a:xfrm>
+          <a:prstGeom prst="rect">
+            <a:avLst/>
+          </a:prstGeom>
+          <a:noFill/>
+          <a:ln/>
+        </p:spPr>
+        <p:txBody>
+          <a:bodyPr wrap="square" lIns="0" tIns="0" rIns="0" bIns="0" rtlCol="0" anchor="ctr"/>
+          <a:lstStyle/>
+          <a:p>
+            <a:pPr algn="ctr" indent="0" marL="0">
+              <a:buNone/>
+            </a:pPr>
+            <a:r>
+              <a:rPr lang="en-US" sz="1300" b="1" dirty="0">
+                <a:solidFill>
+                  <a:srgbClr val="FFFFFF"/>
+                </a:solidFill>
+                <a:latin typeface="Yu Gothic" pitchFamily="34" charset="0"/>
+                <a:ea typeface="Yu Gothic" pitchFamily="34" charset="-122"/>
+                <a:cs typeface="Yu Gothic" pitchFamily="34" charset="-120"/>
+              </a:rPr>
+              <a:t>1</a:t>
+            </a:r>
+            <a:endParaRPr lang="en-US" sz="1300" dirty="0"/>
+          </a:p>
+        </p:txBody>
+      </p:sp>
+      <p:sp>
+        <p:nvSpPr>
+          <p:cNvPr id="8" name="Text 6"/>
+          <p:cNvSpPr txBox="1"/>
+          <p:nvPr/>
+        </p:nvSpPr>
+        <p:spPr>
+          <a:xfrm>
+            <a:off x="1051560" y="2944368"/>
+            <a:ext cx="2834640" cy="731520"/>
           </a:xfrm>
           <a:prstGeom prst="rect">
             <a:avLst/>
@@ -2894,41 +3264,108 @@
           <a:p>
             <a:pPr indent="0" marL="0">
               <a:lnSpc>
-                <a:spcPct val="160000"/>
+                <a:spcPct val="125000"/>
               </a:lnSpc>
               <a:buNone/>
             </a:pPr>
             <a:r>
-              <a:rPr lang="en-US" sz="1650" dirty="0">
-                <a:solidFill>
-                  <a:srgbClr val="3F3933"/>
-                </a:solidFill>
-                <a:latin typeface="Yu Gothic" pitchFamily="34" charset="0"/>
-                <a:ea typeface="Yu Gothic" pitchFamily="34" charset="-122"/>
-                <a:cs typeface="Yu Gothic" pitchFamily="34" charset="-120"/>
-              </a:rPr>
-              <a:t>診断して終わった初回は、2回目の欠席理由をつくります。だから必ず、その日のうちに1つ動くものを持ち帰っていただきます。小さくて構いません。明日の朝に一度使えるものであることのほうが大事です。</a:t>
-            </a:r>
-            <a:endParaRPr lang="en-US" sz="1650" dirty="0"/>
-          </a:p>
-        </p:txBody>
-      </p:sp>
-      <p:sp>
-        <p:nvSpPr>
-          <p:cNvPr id="6" name="Shape 4"/>
+              <a:rPr lang="en-US" sz="1450" b="1" dirty="0">
+                <a:solidFill>
+                  <a:srgbClr val="23201D"/>
+                </a:solidFill>
+                <a:latin typeface="Yu Gothic" pitchFamily="34" charset="0"/>
+                <a:ea typeface="Yu Gothic" pitchFamily="34" charset="-122"/>
+                <a:cs typeface="Yu Gothic" pitchFamily="34" charset="-120"/>
+              </a:rPr>
+              <a:t>いまの使い方を拝見する</a:t>
+            </a:r>
+            <a:endParaRPr lang="en-US" sz="1450" dirty="0"/>
+          </a:p>
+        </p:txBody>
+      </p:sp>
+      <p:sp>
+        <p:nvSpPr>
+          <p:cNvPr id="9" name="Text 7"/>
+          <p:cNvSpPr txBox="1"/>
+          <p:nvPr/>
+        </p:nvSpPr>
+        <p:spPr>
+          <a:xfrm>
+            <a:off x="1051560" y="3703320"/>
+            <a:ext cx="2834640" cy="1188720"/>
+          </a:xfrm>
+          <a:prstGeom prst="rect">
+            <a:avLst/>
+          </a:prstGeom>
+          <a:noFill/>
+          <a:ln/>
+        </p:spPr>
+        <p:txBody>
+          <a:bodyPr wrap="square" lIns="0" tIns="0" rIns="0" bIns="0" rtlCol="0" anchor="ctr"/>
+          <a:lstStyle/>
+          <a:p>
+            <a:pPr indent="0" marL="0">
+              <a:lnSpc>
+                <a:spcPct val="130000"/>
+              </a:lnSpc>
+              <a:buNone/>
+            </a:pPr>
+            <a:r>
+              <a:rPr lang="en-US" sz="1150" dirty="0">
+                <a:solidFill>
+                  <a:srgbClr val="5A534A"/>
+                </a:solidFill>
+                <a:latin typeface="Yu Gothic" pitchFamily="34" charset="0"/>
+                <a:ea typeface="Yu Gothic" pitchFamily="34" charset="-122"/>
+                <a:cs typeface="Yu Gothic" pitchFamily="34" charset="-120"/>
+              </a:rPr>
+              <a:t>20分。普段どおりに操作していただきます。うまくやろうとしなくて大丈夫です</a:t>
+            </a:r>
+            <a:endParaRPr lang="en-US" sz="1150" dirty="0"/>
+          </a:p>
+        </p:txBody>
+      </p:sp>
+      <p:sp>
+        <p:nvSpPr>
+          <p:cNvPr id="10" name="Shape 8"/>
           <p:cNvSpPr/>
           <p:nvPr/>
         </p:nvSpPr>
         <p:spPr>
           <a:xfrm>
-            <a:off x="777240" y="4709160"/>
-            <a:ext cx="10607040" cy="960120"/>
+            <a:off x="4389120" y="2148840"/>
+            <a:ext cx="3383280" cy="2880360"/>
           </a:xfrm>
           <a:prstGeom prst="rect">
             <a:avLst/>
           </a:prstGeom>
           <a:solidFill>
-            <a:srgbClr val="EDE7DB"/>
+            <a:srgbClr val="FFFFFF"/>
+          </a:solidFill>
+          <a:ln w="12700">
+            <a:solidFill>
+              <a:srgbClr val="EDE7DB"/>
+            </a:solidFill>
+            <a:prstDash val="solid"/>
+          </a:ln>
+        </p:spPr>
+      </p:sp>
+      <p:sp>
+        <p:nvSpPr>
+          <p:cNvPr id="11" name="Shape 9"/>
+          <p:cNvSpPr/>
+          <p:nvPr/>
+        </p:nvSpPr>
+        <p:spPr>
+          <a:xfrm>
+            <a:off x="4663440" y="2395728"/>
+            <a:ext cx="438912" cy="438912"/>
+          </a:xfrm>
+          <a:prstGeom prst="ellipse">
+            <a:avLst/>
+          </a:prstGeom>
+          <a:solidFill>
+            <a:srgbClr val="2F4F6B"/>
           </a:solidFill>
           <a:ln w="12700">
             <a:solidFill>
@@ -2940,53 +3377,95 @@
       </p:sp>
       <p:sp>
         <p:nvSpPr>
-          <p:cNvPr id="7" name="Text 5"/>
-          <p:cNvSpPr txBox="1"/>
-          <p:nvPr/>
-        </p:nvSpPr>
-        <p:spPr>
-          <a:xfrm>
-            <a:off x="1051560" y="4800600"/>
-            <a:ext cx="1463040" cy="256032"/>
-          </a:xfrm>
-          <a:prstGeom prst="rect">
-            <a:avLst/>
-          </a:prstGeom>
-          <a:noFill/>
-          <a:ln/>
-        </p:spPr>
-        <p:txBody>
-          <a:bodyPr wrap="square" lIns="0" tIns="0" rIns="0" bIns="0" rtlCol="0" anchor="ctr"/>
-          <a:lstStyle/>
-          <a:p>
-            <a:pPr indent="0" marL="0">
-              <a:buNone/>
-            </a:pPr>
-            <a:r>
-              <a:rPr lang="en-US" sz="900" b="1" spc="150" kern="0" dirty="0">
-                <a:solidFill>
-                  <a:srgbClr val="B04A2F"/>
-                </a:solidFill>
-                <a:latin typeface="Yu Gothic" pitchFamily="34" charset="0"/>
-                <a:ea typeface="Yu Gothic" pitchFamily="34" charset="-122"/>
-                <a:cs typeface="Yu Gothic" pitchFamily="34" charset="-120"/>
-              </a:rPr>
-              <a:t>他社では</a:t>
-            </a:r>
-            <a:endParaRPr lang="en-US" sz="900" dirty="0"/>
-          </a:p>
-        </p:txBody>
-      </p:sp>
-      <p:sp>
-        <p:nvSpPr>
-          <p:cNvPr id="8" name="Text 6"/>
-          <p:cNvSpPr txBox="1"/>
-          <p:nvPr/>
-        </p:nvSpPr>
-        <p:spPr>
-          <a:xfrm>
-            <a:off x="1051560" y="5029200"/>
-            <a:ext cx="10058400" cy="566928"/>
+          <p:cNvPr id="12" name="Text 10"/>
+          <p:cNvSpPr txBox="1"/>
+          <p:nvPr/>
+        </p:nvSpPr>
+        <p:spPr>
+          <a:xfrm>
+            <a:off x="4663440" y="2395728"/>
+            <a:ext cx="438912" cy="438912"/>
+          </a:xfrm>
+          <a:prstGeom prst="rect">
+            <a:avLst/>
+          </a:prstGeom>
+          <a:noFill/>
+          <a:ln/>
+        </p:spPr>
+        <p:txBody>
+          <a:bodyPr wrap="square" lIns="0" tIns="0" rIns="0" bIns="0" rtlCol="0" anchor="ctr"/>
+          <a:lstStyle/>
+          <a:p>
+            <a:pPr algn="ctr" indent="0" marL="0">
+              <a:buNone/>
+            </a:pPr>
+            <a:r>
+              <a:rPr lang="en-US" sz="1300" b="1" dirty="0">
+                <a:solidFill>
+                  <a:srgbClr val="FFFFFF"/>
+                </a:solidFill>
+                <a:latin typeface="Yu Gothic" pitchFamily="34" charset="0"/>
+                <a:ea typeface="Yu Gothic" pitchFamily="34" charset="-122"/>
+                <a:cs typeface="Yu Gothic" pitchFamily="34" charset="-120"/>
+              </a:rPr>
+              <a:t>2</a:t>
+            </a:r>
+            <a:endParaRPr lang="en-US" sz="1300" dirty="0"/>
+          </a:p>
+        </p:txBody>
+      </p:sp>
+      <p:sp>
+        <p:nvSpPr>
+          <p:cNvPr id="13" name="Text 11"/>
+          <p:cNvSpPr txBox="1"/>
+          <p:nvPr/>
+        </p:nvSpPr>
+        <p:spPr>
+          <a:xfrm>
+            <a:off x="4663440" y="2944368"/>
+            <a:ext cx="2834640" cy="731520"/>
+          </a:xfrm>
+          <a:prstGeom prst="rect">
+            <a:avLst/>
+          </a:prstGeom>
+          <a:noFill/>
+          <a:ln/>
+        </p:spPr>
+        <p:txBody>
+          <a:bodyPr wrap="square" lIns="0" tIns="0" rIns="0" bIns="0" rtlCol="0" anchor="ctr"/>
+          <a:lstStyle/>
+          <a:p>
+            <a:pPr indent="0" marL="0">
+              <a:lnSpc>
+                <a:spcPct val="125000"/>
+              </a:lnSpc>
+              <a:buNone/>
+            </a:pPr>
+            <a:r>
+              <a:rPr lang="en-US" sz="1450" b="1" dirty="0">
+                <a:solidFill>
+                  <a:srgbClr val="23201D"/>
+                </a:solidFill>
+                <a:latin typeface="Yu Gothic" pitchFamily="34" charset="0"/>
+                <a:ea typeface="Yu Gothic" pitchFamily="34" charset="-122"/>
+                <a:cs typeface="Yu Gothic" pitchFamily="34" charset="-120"/>
+              </a:rPr>
+              <a:t>業務を棚卸しする</a:t>
+            </a:r>
+            <a:endParaRPr lang="en-US" sz="1450" dirty="0"/>
+          </a:p>
+        </p:txBody>
+      </p:sp>
+      <p:sp>
+        <p:nvSpPr>
+          <p:cNvPr id="14" name="Text 12"/>
+          <p:cNvSpPr txBox="1"/>
+          <p:nvPr/>
+        </p:nvSpPr>
+        <p:spPr>
+          <a:xfrm>
+            <a:off x="4663440" y="3703320"/>
+            <a:ext cx="2834640" cy="1188720"/>
           </a:xfrm>
           <a:prstGeom prst="rect">
             <a:avLst/>
@@ -3005,23 +3484,196 @@
               <a:buNone/>
             </a:pPr>
             <a:r>
-              <a:rPr lang="en-US" sz="1250" dirty="0">
-                <a:solidFill>
-                  <a:srgbClr val="3F3933"/>
-                </a:solidFill>
-                <a:latin typeface="Yu Gothic" pitchFamily="34" charset="0"/>
-                <a:ea typeface="Yu Gothic" pitchFamily="34" charset="-122"/>
-                <a:cs typeface="Yu Gothic" pitchFamily="34" charset="-120"/>
-              </a:rPr>
-              <a:t>ある会社では、初回に作ったのは「お断りメールの下書き」1本だけでした。ただ、それを翌朝に使ったことで、2回目以降の宿題が一度も止まりませんでした。</a:t>
-            </a:r>
-            <a:endParaRPr lang="en-US" sz="1250" dirty="0"/>
-          </a:p>
-        </p:txBody>
-      </p:sp>
-      <p:sp>
-        <p:nvSpPr>
-          <p:cNvPr id="9" name="Text 7"/>
+              <a:rPr lang="en-US" sz="1150" dirty="0">
+                <a:solidFill>
+                  <a:srgbClr val="5A534A"/>
+                </a:solidFill>
+                <a:latin typeface="Yu Gothic" pitchFamily="34" charset="0"/>
+                <a:ea typeface="Yu Gothic" pitchFamily="34" charset="-122"/>
+                <a:cs typeface="Yu Gothic" pitchFamily="34" charset="-120"/>
+              </a:rPr>
+              <a:t>実際の一週間を聞きながら、6列の表をその場で埋めます</a:t>
+            </a:r>
+            <a:endParaRPr lang="en-US" sz="1150" dirty="0"/>
+          </a:p>
+        </p:txBody>
+      </p:sp>
+      <p:sp>
+        <p:nvSpPr>
+          <p:cNvPr id="15" name="Shape 13"/>
+          <p:cNvSpPr/>
+          <p:nvPr/>
+        </p:nvSpPr>
+        <p:spPr>
+          <a:xfrm>
+            <a:off x="8001000" y="2148840"/>
+            <a:ext cx="3383280" cy="2880360"/>
+          </a:xfrm>
+          <a:prstGeom prst="rect">
+            <a:avLst/>
+          </a:prstGeom>
+          <a:solidFill>
+            <a:srgbClr val="FFFFFF"/>
+          </a:solidFill>
+          <a:ln w="12700">
+            <a:solidFill>
+              <a:srgbClr val="EDE7DB"/>
+            </a:solidFill>
+            <a:prstDash val="solid"/>
+          </a:ln>
+        </p:spPr>
+      </p:sp>
+      <p:sp>
+        <p:nvSpPr>
+          <p:cNvPr id="16" name="Shape 14"/>
+          <p:cNvSpPr/>
+          <p:nvPr/>
+        </p:nvSpPr>
+        <p:spPr>
+          <a:xfrm>
+            <a:off x="8275320" y="2395728"/>
+            <a:ext cx="438912" cy="438912"/>
+          </a:xfrm>
+          <a:prstGeom prst="ellipse">
+            <a:avLst/>
+          </a:prstGeom>
+          <a:solidFill>
+            <a:srgbClr val="2F4F6B"/>
+          </a:solidFill>
+          <a:ln w="12700">
+            <a:solidFill>
+              <a:srgbClr val="333333"/>
+            </a:solidFill>
+            <a:prstDash val="solid"/>
+          </a:ln>
+        </p:spPr>
+      </p:sp>
+      <p:sp>
+        <p:nvSpPr>
+          <p:cNvPr id="17" name="Text 15"/>
+          <p:cNvSpPr txBox="1"/>
+          <p:nvPr/>
+        </p:nvSpPr>
+        <p:spPr>
+          <a:xfrm>
+            <a:off x="8275320" y="2395728"/>
+            <a:ext cx="438912" cy="438912"/>
+          </a:xfrm>
+          <a:prstGeom prst="rect">
+            <a:avLst/>
+          </a:prstGeom>
+          <a:noFill/>
+          <a:ln/>
+        </p:spPr>
+        <p:txBody>
+          <a:bodyPr wrap="square" lIns="0" tIns="0" rIns="0" bIns="0" rtlCol="0" anchor="ctr"/>
+          <a:lstStyle/>
+          <a:p>
+            <a:pPr algn="ctr" indent="0" marL="0">
+              <a:buNone/>
+            </a:pPr>
+            <a:r>
+              <a:rPr lang="en-US" sz="1300" b="1" dirty="0">
+                <a:solidFill>
+                  <a:srgbClr val="FFFFFF"/>
+                </a:solidFill>
+                <a:latin typeface="Yu Gothic" pitchFamily="34" charset="0"/>
+                <a:ea typeface="Yu Gothic" pitchFamily="34" charset="-122"/>
+                <a:cs typeface="Yu Gothic" pitchFamily="34" charset="-120"/>
+              </a:rPr>
+              <a:t>3</a:t>
+            </a:r>
+            <a:endParaRPr lang="en-US" sz="1300" dirty="0"/>
+          </a:p>
+        </p:txBody>
+      </p:sp>
+      <p:sp>
+        <p:nvSpPr>
+          <p:cNvPr id="18" name="Text 16"/>
+          <p:cNvSpPr txBox="1"/>
+          <p:nvPr/>
+        </p:nvSpPr>
+        <p:spPr>
+          <a:xfrm>
+            <a:off x="8275320" y="2944368"/>
+            <a:ext cx="2834640" cy="731520"/>
+          </a:xfrm>
+          <a:prstGeom prst="rect">
+            <a:avLst/>
+          </a:prstGeom>
+          <a:noFill/>
+          <a:ln/>
+        </p:spPr>
+        <p:txBody>
+          <a:bodyPr wrap="square" lIns="0" tIns="0" rIns="0" bIns="0" rtlCol="0" anchor="ctr"/>
+          <a:lstStyle/>
+          <a:p>
+            <a:pPr indent="0" marL="0">
+              <a:lnSpc>
+                <a:spcPct val="125000"/>
+              </a:lnSpc>
+              <a:buNone/>
+            </a:pPr>
+            <a:r>
+              <a:rPr lang="en-US" sz="1450" b="1" dirty="0">
+                <a:solidFill>
+                  <a:srgbClr val="23201D"/>
+                </a:solidFill>
+                <a:latin typeface="Yu Gothic" pitchFamily="34" charset="0"/>
+                <a:ea typeface="Yu Gothic" pitchFamily="34" charset="-122"/>
+                <a:cs typeface="Yu Gothic" pitchFamily="34" charset="-120"/>
+              </a:rPr>
+              <a:t>1つ、その場で解かせる</a:t>
+            </a:r>
+            <a:endParaRPr lang="en-US" sz="1450" dirty="0"/>
+          </a:p>
+        </p:txBody>
+      </p:sp>
+      <p:sp>
+        <p:nvSpPr>
+          <p:cNvPr id="19" name="Text 17"/>
+          <p:cNvSpPr txBox="1"/>
+          <p:nvPr/>
+        </p:nvSpPr>
+        <p:spPr>
+          <a:xfrm>
+            <a:off x="8275320" y="3703320"/>
+            <a:ext cx="2834640" cy="1188720"/>
+          </a:xfrm>
+          <a:prstGeom prst="rect">
+            <a:avLst/>
+          </a:prstGeom>
+          <a:noFill/>
+          <a:ln/>
+        </p:spPr>
+        <p:txBody>
+          <a:bodyPr wrap="square" lIns="0" tIns="0" rIns="0" bIns="0" rtlCol="0" anchor="ctr"/>
+          <a:lstStyle/>
+          <a:p>
+            <a:pPr indent="0" marL="0">
+              <a:lnSpc>
+                <a:spcPct val="130000"/>
+              </a:lnSpc>
+              <a:buNone/>
+            </a:pPr>
+            <a:r>
+              <a:rPr lang="en-US" sz="1150" dirty="0">
+                <a:solidFill>
+                  <a:srgbClr val="5A534A"/>
+                </a:solidFill>
+                <a:latin typeface="Yu Gothic" pitchFamily="34" charset="0"/>
+                <a:ea typeface="Yu Gothic" pitchFamily="34" charset="-122"/>
+                <a:cs typeface="Yu Gothic" pitchFamily="34" charset="-120"/>
+              </a:rPr>
+              <a:t>上位3つのうち1つを今日のうちに動かし、指示文を保存して持ち帰ります</a:t>
+            </a:r>
+            <a:endParaRPr lang="en-US" sz="1150" dirty="0"/>
+          </a:p>
+        </p:txBody>
+      </p:sp>
+      <p:sp>
+        <p:nvSpPr>
+          <p:cNvPr id="20" name="Text 18"/>
           <p:cNvSpPr txBox="1"/>
           <p:nvPr/>
         </p:nvSpPr>
@@ -3060,7 +3712,7 @@
       </p:sp>
       <p:sp>
         <p:nvSpPr>
-          <p:cNvPr id="10" name="Text 8"/>
+          <p:cNvPr id="21" name="Text 19"/>
           <p:cNvSpPr txBox="1"/>
           <p:nvPr/>
         </p:nvSpPr>
@@ -3091,7 +3743,7 @@
                 <a:ea typeface="Yu Gothic" pitchFamily="34" charset="-122"/>
                 <a:cs typeface="Yu Gothic" pitchFamily="34" charset="-120"/>
               </a:rPr>
-              <a:t>ここだけは</a:t>
+              <a:t>演習</a:t>
             </a:r>
             <a:endParaRPr lang="en-US" sz="900" dirty="0"/>
           </a:p>
@@ -3108,6 +3760,1532 @@
 <file path=ppt/slides/slide12.xml><?xml version="1.0" encoding="utf-8"?>
 <p:sld xmlns:a="http://schemas.openxmlformats.org/drawingml/2006/main" xmlns:r="http://schemas.openxmlformats.org/officeDocument/2006/relationships" xmlns:p="http://schemas.openxmlformats.org/presentationml/2006/main">
   <p:cSld name="Slide 12">
+    <p:bg>
+      <p:bgPr>
+        <a:solidFill>
+          <a:srgbClr val="F6F2EA"/>
+        </a:solidFill>
+      </p:bgPr>
+    </p:bg>
+    <p:spTree>
+      <p:nvGrpSpPr>
+        <p:cNvPr id="1" name=""/>
+        <p:cNvGrpSpPr/>
+        <p:nvPr/>
+      </p:nvGrpSpPr>
+      <p:grpSpPr>
+        <a:xfrm>
+          <a:off x="0" y="0"/>
+          <a:ext cx="0" cy="0"/>
+          <a:chOff x="0" y="0"/>
+          <a:chExt cx="0" cy="0"/>
+        </a:xfrm>
+      </p:grpSpPr>
+      <p:sp>
+        <p:nvSpPr>
+          <p:cNvPr id="2" name="Text 0"/>
+          <p:cNvSpPr txBox="1"/>
+          <p:nvPr/>
+        </p:nvSpPr>
+        <p:spPr>
+          <a:xfrm>
+            <a:off x="777240" y="566928"/>
+            <a:ext cx="10607040" cy="274320"/>
+          </a:xfrm>
+          <a:prstGeom prst="rect">
+            <a:avLst/>
+          </a:prstGeom>
+          <a:noFill/>
+          <a:ln/>
+        </p:spPr>
+        <p:txBody>
+          <a:bodyPr wrap="square" lIns="0" tIns="0" rIns="0" bIns="0" rtlCol="0" anchor="ctr"/>
+          <a:lstStyle/>
+          <a:p>
+            <a:pPr indent="0" marL="0">
+              <a:buNone/>
+            </a:pPr>
+            <a:r>
+              <a:rPr lang="en-US" sz="1100" b="1" spc="250" kern="0" dirty="0">
+                <a:solidFill>
+                  <a:srgbClr val="3B6B4A"/>
+                </a:solidFill>
+                <a:latin typeface="Yu Gothic" pitchFamily="34" charset="0"/>
+                <a:ea typeface="Yu Gothic" pitchFamily="34" charset="-122"/>
+                <a:cs typeface="Yu Gothic" pitchFamily="34" charset="-120"/>
+              </a:rPr>
+              <a:t>業務への組み込み</a:t>
+            </a:r>
+            <a:endParaRPr lang="en-US" sz="1100" dirty="0"/>
+          </a:p>
+        </p:txBody>
+      </p:sp>
+      <p:sp>
+        <p:nvSpPr>
+          <p:cNvPr id="3" name="Text 1"/>
+          <p:cNvSpPr txBox="1"/>
+          <p:nvPr/>
+        </p:nvSpPr>
+        <p:spPr>
+          <a:xfrm>
+            <a:off x="777240" y="896112"/>
+            <a:ext cx="10607040" cy="640080"/>
+          </a:xfrm>
+          <a:prstGeom prst="rect">
+            <a:avLst/>
+          </a:prstGeom>
+          <a:noFill/>
+          <a:ln/>
+        </p:spPr>
+        <p:txBody>
+          <a:bodyPr wrap="square" lIns="0" tIns="0" rIns="0" bIns="0" rtlCol="0" anchor="ctr"/>
+          <a:lstStyle/>
+          <a:p>
+            <a:pPr indent="0" marL="0">
+              <a:buNone/>
+            </a:pPr>
+            <a:r>
+              <a:rPr lang="en-US" sz="2600" b="1" dirty="0">
+                <a:solidFill>
+                  <a:srgbClr val="23201D"/>
+                </a:solidFill>
+                <a:latin typeface="Yu Gothic" pitchFamily="34" charset="0"/>
+                <a:ea typeface="Yu Gothic" pitchFamily="34" charset="-122"/>
+                <a:cs typeface="Yu Gothic" pitchFamily="34" charset="-120"/>
+              </a:rPr>
+              <a:t>帰る前に決めること</a:t>
+            </a:r>
+            <a:endParaRPr lang="en-US" sz="2600" dirty="0"/>
+          </a:p>
+        </p:txBody>
+      </p:sp>
+      <p:sp>
+        <p:nvSpPr>
+          <p:cNvPr id="4" name="Text 2"/>
+          <p:cNvSpPr txBox="1"/>
+          <p:nvPr/>
+        </p:nvSpPr>
+        <p:spPr>
+          <a:xfrm>
+            <a:off x="777240" y="1572768"/>
+            <a:ext cx="10607040" cy="320040"/>
+          </a:xfrm>
+          <a:prstGeom prst="rect">
+            <a:avLst/>
+          </a:prstGeom>
+          <a:noFill/>
+          <a:ln/>
+        </p:spPr>
+        <p:txBody>
+          <a:bodyPr wrap="square" lIns="0" tIns="0" rIns="0" bIns="0" rtlCol="0" anchor="ctr"/>
+          <a:lstStyle/>
+          <a:p>
+            <a:pPr indent="0" marL="0">
+              <a:buNone/>
+            </a:pPr>
+            <a:r>
+              <a:rPr lang="en-US" sz="1250" b="1" dirty="0">
+                <a:solidFill>
+                  <a:srgbClr val="3B6B4A"/>
+                </a:solidFill>
+                <a:latin typeface="Yu Gothic" pitchFamily="34" charset="0"/>
+                <a:ea typeface="Yu Gothic" pitchFamily="34" charset="-122"/>
+                <a:cs typeface="Yu Gothic" pitchFamily="34" charset="-120"/>
+              </a:rPr>
+              <a:t>ここを決めないと、持ち帰っても使われません。紙に書きます。</a:t>
+            </a:r>
+            <a:endParaRPr lang="en-US" sz="1250" dirty="0"/>
+          </a:p>
+        </p:txBody>
+      </p:sp>
+      <p:sp>
+        <p:nvSpPr>
+          <p:cNvPr id="5" name="Shape 3"/>
+          <p:cNvSpPr/>
+          <p:nvPr/>
+        </p:nvSpPr>
+        <p:spPr>
+          <a:xfrm>
+            <a:off x="777240" y="2103120"/>
+            <a:ext cx="10607040" cy="914400"/>
+          </a:xfrm>
+          <a:prstGeom prst="rect">
+            <a:avLst/>
+          </a:prstGeom>
+          <a:solidFill>
+            <a:srgbClr val="FFFFFF"/>
+          </a:solidFill>
+          <a:ln w="12700">
+            <a:solidFill>
+              <a:srgbClr val="EDE7DB"/>
+            </a:solidFill>
+            <a:prstDash val="solid"/>
+          </a:ln>
+        </p:spPr>
+      </p:sp>
+      <p:sp>
+        <p:nvSpPr>
+          <p:cNvPr id="6" name="Shape 4"/>
+          <p:cNvSpPr/>
+          <p:nvPr/>
+        </p:nvSpPr>
+        <p:spPr>
+          <a:xfrm>
+            <a:off x="777240" y="2103120"/>
+            <a:ext cx="54864" cy="914400"/>
+          </a:xfrm>
+          <a:prstGeom prst="rect">
+            <a:avLst/>
+          </a:prstGeom>
+          <a:solidFill>
+            <a:srgbClr val="3B6B4A"/>
+          </a:solidFill>
+          <a:ln w="12700">
+            <a:solidFill>
+              <a:srgbClr val="333333"/>
+            </a:solidFill>
+            <a:prstDash val="solid"/>
+          </a:ln>
+        </p:spPr>
+      </p:sp>
+      <p:sp>
+        <p:nvSpPr>
+          <p:cNvPr id="7" name="Text 5"/>
+          <p:cNvSpPr txBox="1"/>
+          <p:nvPr/>
+        </p:nvSpPr>
+        <p:spPr>
+          <a:xfrm>
+            <a:off x="1143000" y="2176272"/>
+            <a:ext cx="2757830" cy="768096"/>
+          </a:xfrm>
+          <a:prstGeom prst="rect">
+            <a:avLst/>
+          </a:prstGeom>
+          <a:noFill/>
+          <a:ln/>
+        </p:spPr>
+        <p:txBody>
+          <a:bodyPr wrap="square" lIns="0" tIns="0" rIns="0" bIns="0" rtlCol="0" anchor="ctr"/>
+          <a:lstStyle/>
+          <a:p>
+            <a:pPr indent="0" marL="0">
+              <a:buNone/>
+            </a:pPr>
+            <a:r>
+              <a:rPr lang="en-US" sz="1400" b="1" dirty="0">
+                <a:solidFill>
+                  <a:srgbClr val="3B6B4A"/>
+                </a:solidFill>
+                <a:latin typeface="Yu Gothic" pitchFamily="34" charset="0"/>
+                <a:ea typeface="Yu Gothic" pitchFamily="34" charset="-122"/>
+                <a:cs typeface="Yu Gothic" pitchFamily="34" charset="-120"/>
+              </a:rPr>
+              <a:t>いつ使うか</a:t>
+            </a:r>
+            <a:endParaRPr lang="en-US" sz="1400" dirty="0"/>
+          </a:p>
+        </p:txBody>
+      </p:sp>
+      <p:sp>
+        <p:nvSpPr>
+          <p:cNvPr id="8" name="Text 6"/>
+          <p:cNvSpPr txBox="1"/>
+          <p:nvPr/>
+        </p:nvSpPr>
+        <p:spPr>
+          <a:xfrm>
+            <a:off x="4006901" y="2176272"/>
+            <a:ext cx="7011619" cy="768096"/>
+          </a:xfrm>
+          <a:prstGeom prst="rect">
+            <a:avLst/>
+          </a:prstGeom>
+          <a:noFill/>
+          <a:ln/>
+        </p:spPr>
+        <p:txBody>
+          <a:bodyPr wrap="square" lIns="0" tIns="0" rIns="0" bIns="0" rtlCol="0" anchor="ctr"/>
+          <a:lstStyle/>
+          <a:p>
+            <a:pPr indent="0" marL="0">
+              <a:lnSpc>
+                <a:spcPct val="130000"/>
+              </a:lnSpc>
+              <a:buNone/>
+            </a:pPr>
+            <a:r>
+              <a:rPr lang="en-US" sz="1250" dirty="0">
+                <a:solidFill>
+                  <a:srgbClr val="3F3933"/>
+                </a:solidFill>
+                <a:latin typeface="Yu Gothic" pitchFamily="34" charset="0"/>
+                <a:ea typeface="Yu Gothic" pitchFamily="34" charset="-122"/>
+                <a:cs typeface="Yu Gothic" pitchFamily="34" charset="-120"/>
+              </a:rPr>
+              <a:t>「明日の朝いち、見積を書く前に」まで具体的に決めます</a:t>
+            </a:r>
+            <a:endParaRPr lang="en-US" sz="1250" dirty="0"/>
+          </a:p>
+        </p:txBody>
+      </p:sp>
+      <p:sp>
+        <p:nvSpPr>
+          <p:cNvPr id="9" name="Shape 7"/>
+          <p:cNvSpPr/>
+          <p:nvPr/>
+        </p:nvSpPr>
+        <p:spPr>
+          <a:xfrm>
+            <a:off x="777240" y="3154680"/>
+            <a:ext cx="10607040" cy="914400"/>
+          </a:xfrm>
+          <a:prstGeom prst="rect">
+            <a:avLst/>
+          </a:prstGeom>
+          <a:solidFill>
+            <a:srgbClr val="FFFFFF"/>
+          </a:solidFill>
+          <a:ln w="12700">
+            <a:solidFill>
+              <a:srgbClr val="EDE7DB"/>
+            </a:solidFill>
+            <a:prstDash val="solid"/>
+          </a:ln>
+        </p:spPr>
+      </p:sp>
+      <p:sp>
+        <p:nvSpPr>
+          <p:cNvPr id="10" name="Shape 8"/>
+          <p:cNvSpPr/>
+          <p:nvPr/>
+        </p:nvSpPr>
+        <p:spPr>
+          <a:xfrm>
+            <a:off x="777240" y="3154680"/>
+            <a:ext cx="54864" cy="914400"/>
+          </a:xfrm>
+          <a:prstGeom prst="rect">
+            <a:avLst/>
+          </a:prstGeom>
+          <a:solidFill>
+            <a:srgbClr val="3B6B4A"/>
+          </a:solidFill>
+          <a:ln w="12700">
+            <a:solidFill>
+              <a:srgbClr val="333333"/>
+            </a:solidFill>
+            <a:prstDash val="solid"/>
+          </a:ln>
+        </p:spPr>
+      </p:sp>
+      <p:sp>
+        <p:nvSpPr>
+          <p:cNvPr id="11" name="Text 9"/>
+          <p:cNvSpPr txBox="1"/>
+          <p:nvPr/>
+        </p:nvSpPr>
+        <p:spPr>
+          <a:xfrm>
+            <a:off x="1143000" y="3227832"/>
+            <a:ext cx="2757830" cy="768096"/>
+          </a:xfrm>
+          <a:prstGeom prst="rect">
+            <a:avLst/>
+          </a:prstGeom>
+          <a:noFill/>
+          <a:ln/>
+        </p:spPr>
+        <p:txBody>
+          <a:bodyPr wrap="square" lIns="0" tIns="0" rIns="0" bIns="0" rtlCol="0" anchor="ctr"/>
+          <a:lstStyle/>
+          <a:p>
+            <a:pPr indent="0" marL="0">
+              <a:buNone/>
+            </a:pPr>
+            <a:r>
+              <a:rPr lang="en-US" sz="1400" b="1" dirty="0">
+                <a:solidFill>
+                  <a:srgbClr val="3B6B4A"/>
+                </a:solidFill>
+                <a:latin typeface="Yu Gothic" pitchFamily="34" charset="0"/>
+                <a:ea typeface="Yu Gothic" pitchFamily="34" charset="-122"/>
+                <a:cs typeface="Yu Gothic" pitchFamily="34" charset="-120"/>
+              </a:rPr>
+              <a:t>誰が使うか</a:t>
+            </a:r>
+            <a:endParaRPr lang="en-US" sz="1400" dirty="0"/>
+          </a:p>
+        </p:txBody>
+      </p:sp>
+      <p:sp>
+        <p:nvSpPr>
+          <p:cNvPr id="12" name="Text 10"/>
+          <p:cNvSpPr txBox="1"/>
+          <p:nvPr/>
+        </p:nvSpPr>
+        <p:spPr>
+          <a:xfrm>
+            <a:off x="4006901" y="3227832"/>
+            <a:ext cx="7011619" cy="768096"/>
+          </a:xfrm>
+          <a:prstGeom prst="rect">
+            <a:avLst/>
+          </a:prstGeom>
+          <a:noFill/>
+          <a:ln/>
+        </p:spPr>
+        <p:txBody>
+          <a:bodyPr wrap="square" lIns="0" tIns="0" rIns="0" bIns="0" rtlCol="0" anchor="ctr"/>
+          <a:lstStyle/>
+          <a:p>
+            <a:pPr indent="0" marL="0">
+              <a:lnSpc>
+                <a:spcPct val="130000"/>
+              </a:lnSpc>
+              <a:buNone/>
+            </a:pPr>
+            <a:r>
+              <a:rPr lang="en-US" sz="1250" dirty="0">
+                <a:solidFill>
+                  <a:srgbClr val="3F3933"/>
+                </a:solidFill>
+                <a:latin typeface="Yu Gothic" pitchFamily="34" charset="0"/>
+                <a:ea typeface="Yu Gothic" pitchFamily="34" charset="-122"/>
+                <a:cs typeface="Yu Gothic" pitchFamily="34" charset="-120"/>
+              </a:rPr>
+              <a:t>当面は社長ご自身です。社員に渡すのは第3回から</a:t>
+            </a:r>
+            <a:endParaRPr lang="en-US" sz="1250" dirty="0"/>
+          </a:p>
+        </p:txBody>
+      </p:sp>
+      <p:sp>
+        <p:nvSpPr>
+          <p:cNvPr id="13" name="Shape 11"/>
+          <p:cNvSpPr/>
+          <p:nvPr/>
+        </p:nvSpPr>
+        <p:spPr>
+          <a:xfrm>
+            <a:off x="777240" y="4206240"/>
+            <a:ext cx="10607040" cy="914400"/>
+          </a:xfrm>
+          <a:prstGeom prst="rect">
+            <a:avLst/>
+          </a:prstGeom>
+          <a:solidFill>
+            <a:srgbClr val="FFFFFF"/>
+          </a:solidFill>
+          <a:ln w="12700">
+            <a:solidFill>
+              <a:srgbClr val="EDE7DB"/>
+            </a:solidFill>
+            <a:prstDash val="solid"/>
+          </a:ln>
+        </p:spPr>
+      </p:sp>
+      <p:sp>
+        <p:nvSpPr>
+          <p:cNvPr id="14" name="Shape 12"/>
+          <p:cNvSpPr/>
+          <p:nvPr/>
+        </p:nvSpPr>
+        <p:spPr>
+          <a:xfrm>
+            <a:off x="777240" y="4206240"/>
+            <a:ext cx="54864" cy="914400"/>
+          </a:xfrm>
+          <a:prstGeom prst="rect">
+            <a:avLst/>
+          </a:prstGeom>
+          <a:solidFill>
+            <a:srgbClr val="3B6B4A"/>
+          </a:solidFill>
+          <a:ln w="12700">
+            <a:solidFill>
+              <a:srgbClr val="333333"/>
+            </a:solidFill>
+            <a:prstDash val="solid"/>
+          </a:ln>
+        </p:spPr>
+      </p:sp>
+      <p:sp>
+        <p:nvSpPr>
+          <p:cNvPr id="15" name="Text 13"/>
+          <p:cNvSpPr txBox="1"/>
+          <p:nvPr/>
+        </p:nvSpPr>
+        <p:spPr>
+          <a:xfrm>
+            <a:off x="1143000" y="4279392"/>
+            <a:ext cx="2757830" cy="768096"/>
+          </a:xfrm>
+          <a:prstGeom prst="rect">
+            <a:avLst/>
+          </a:prstGeom>
+          <a:noFill/>
+          <a:ln/>
+        </p:spPr>
+        <p:txBody>
+          <a:bodyPr wrap="square" lIns="0" tIns="0" rIns="0" bIns="0" rtlCol="0" anchor="ctr"/>
+          <a:lstStyle/>
+          <a:p>
+            <a:pPr indent="0" marL="0">
+              <a:buNone/>
+            </a:pPr>
+            <a:r>
+              <a:rPr lang="en-US" sz="1400" b="1" dirty="0">
+                <a:solidFill>
+                  <a:srgbClr val="3B6B4A"/>
+                </a:solidFill>
+                <a:latin typeface="Yu Gothic" pitchFamily="34" charset="0"/>
+                <a:ea typeface="Yu Gothic" pitchFamily="34" charset="-122"/>
+                <a:cs typeface="Yu Gothic" pitchFamily="34" charset="-120"/>
+              </a:rPr>
+              <a:t>何を確認するか</a:t>
+            </a:r>
+            <a:endParaRPr lang="en-US" sz="1400" dirty="0"/>
+          </a:p>
+        </p:txBody>
+      </p:sp>
+      <p:sp>
+        <p:nvSpPr>
+          <p:cNvPr id="16" name="Text 14"/>
+          <p:cNvSpPr txBox="1"/>
+          <p:nvPr/>
+        </p:nvSpPr>
+        <p:spPr>
+          <a:xfrm>
+            <a:off x="4006901" y="4279392"/>
+            <a:ext cx="7011619" cy="768096"/>
+          </a:xfrm>
+          <a:prstGeom prst="rect">
+            <a:avLst/>
+          </a:prstGeom>
+          <a:noFill/>
+          <a:ln/>
+        </p:spPr>
+        <p:txBody>
+          <a:bodyPr wrap="square" lIns="0" tIns="0" rIns="0" bIns="0" rtlCol="0" anchor="ctr"/>
+          <a:lstStyle/>
+          <a:p>
+            <a:pPr indent="0" marL="0">
+              <a:lnSpc>
+                <a:spcPct val="130000"/>
+              </a:lnSpc>
+              <a:buNone/>
+            </a:pPr>
+            <a:r>
+              <a:rPr lang="en-US" sz="1250" dirty="0">
+                <a:solidFill>
+                  <a:srgbClr val="3F3933"/>
+                </a:solidFill>
+                <a:latin typeface="Yu Gothic" pitchFamily="34" charset="0"/>
+                <a:ea typeface="Yu Gothic" pitchFamily="34" charset="-122"/>
+                <a:cs typeface="Yu Gothic" pitchFamily="34" charset="-120"/>
+              </a:rPr>
+              <a:t>出てきた金額と数字は、提出前に必ず目視で確認します</a:t>
+            </a:r>
+            <a:endParaRPr lang="en-US" sz="1250" dirty="0"/>
+          </a:p>
+        </p:txBody>
+      </p:sp>
+      <p:sp>
+        <p:nvSpPr>
+          <p:cNvPr id="17" name="Text 15"/>
+          <p:cNvSpPr txBox="1"/>
+          <p:nvPr/>
+        </p:nvSpPr>
+        <p:spPr>
+          <a:xfrm>
+            <a:off x="777240" y="6382512"/>
+            <a:ext cx="7424928" cy="256032"/>
+          </a:xfrm>
+          <a:prstGeom prst="rect">
+            <a:avLst/>
+          </a:prstGeom>
+          <a:noFill/>
+          <a:ln/>
+        </p:spPr>
+        <p:txBody>
+          <a:bodyPr wrap="square" lIns="0" tIns="0" rIns="0" bIns="0" rtlCol="0" anchor="ctr"/>
+          <a:lstStyle/>
+          <a:p>
+            <a:pPr indent="0" marL="0">
+              <a:buNone/>
+            </a:pPr>
+            <a:r>
+              <a:rPr lang="en-US" sz="900" dirty="0">
+                <a:solidFill>
+                  <a:srgbClr val="8A8177"/>
+                </a:solidFill>
+                <a:latin typeface="Yu Gothic" pitchFamily="34" charset="0"/>
+                <a:ea typeface="Yu Gothic" pitchFamily="34" charset="-122"/>
+                <a:cs typeface="Yu Gothic" pitchFamily="34" charset="-120"/>
+              </a:rPr>
+              <a:t>第1回　現状把握と地図づくり</a:t>
+            </a:r>
+            <a:endParaRPr lang="en-US" sz="900" dirty="0"/>
+          </a:p>
+        </p:txBody>
+      </p:sp>
+      <p:sp>
+        <p:nvSpPr>
+          <p:cNvPr id="18" name="Text 16"/>
+          <p:cNvSpPr txBox="1"/>
+          <p:nvPr/>
+        </p:nvSpPr>
+        <p:spPr>
+          <a:xfrm>
+            <a:off x="8202168" y="6382512"/>
+            <a:ext cx="3182112" cy="256032"/>
+          </a:xfrm>
+          <a:prstGeom prst="rect">
+            <a:avLst/>
+          </a:prstGeom>
+          <a:noFill/>
+          <a:ln/>
+        </p:spPr>
+        <p:txBody>
+          <a:bodyPr wrap="square" lIns="0" tIns="0" rIns="0" bIns="0" rtlCol="0" anchor="ctr"/>
+          <a:lstStyle/>
+          <a:p>
+            <a:pPr algn="r" indent="0" marL="0">
+              <a:buNone/>
+            </a:pPr>
+            <a:r>
+              <a:rPr lang="en-US" sz="900" dirty="0">
+                <a:solidFill>
+                  <a:srgbClr val="8A8177"/>
+                </a:solidFill>
+                <a:latin typeface="Yu Gothic" pitchFamily="34" charset="0"/>
+                <a:ea typeface="Yu Gothic" pitchFamily="34" charset="-122"/>
+                <a:cs typeface="Yu Gothic" pitchFamily="34" charset="-120"/>
+              </a:rPr>
+              <a:t>組み込み</a:t>
+            </a:r>
+            <a:endParaRPr lang="en-US" sz="900" dirty="0"/>
+          </a:p>
+        </p:txBody>
+      </p:sp>
+    </p:spTree>
+  </p:cSld>
+  <p:clrMapOvr>
+    <a:masterClrMapping/>
+  </p:clrMapOvr>
+</p:sld>
+</file>
+
+<file path=ppt/slides/slide13.xml><?xml version="1.0" encoding="utf-8"?>
+<p:sld xmlns:a="http://schemas.openxmlformats.org/drawingml/2006/main" xmlns:r="http://schemas.openxmlformats.org/officeDocument/2006/relationships" xmlns:p="http://schemas.openxmlformats.org/presentationml/2006/main">
+  <p:cSld name="Slide 13">
+    <p:bg>
+      <p:bgPr>
+        <a:solidFill>
+          <a:srgbClr val="F6F2EA"/>
+        </a:solidFill>
+      </p:bgPr>
+    </p:bg>
+    <p:spTree>
+      <p:nvGrpSpPr>
+        <p:cNvPr id="1" name=""/>
+        <p:cNvGrpSpPr/>
+        <p:nvPr/>
+      </p:nvGrpSpPr>
+      <p:grpSpPr>
+        <a:xfrm>
+          <a:off x="0" y="0"/>
+          <a:ext cx="0" cy="0"/>
+          <a:chOff x="0" y="0"/>
+          <a:chExt cx="0" cy="0"/>
+        </a:xfrm>
+      </p:grpSpPr>
+      <p:sp>
+        <p:nvSpPr>
+          <p:cNvPr id="2" name="Text 0"/>
+          <p:cNvSpPr txBox="1"/>
+          <p:nvPr/>
+        </p:nvSpPr>
+        <p:spPr>
+          <a:xfrm>
+            <a:off x="777240" y="566928"/>
+            <a:ext cx="10607040" cy="274320"/>
+          </a:xfrm>
+          <a:prstGeom prst="rect">
+            <a:avLst/>
+          </a:prstGeom>
+          <a:noFill/>
+          <a:ln/>
+        </p:spPr>
+        <p:txBody>
+          <a:bodyPr wrap="square" lIns="0" tIns="0" rIns="0" bIns="0" rtlCol="0" anchor="ctr"/>
+          <a:lstStyle/>
+          <a:p>
+            <a:pPr indent="0" marL="0">
+              <a:buNone/>
+            </a:pPr>
+            <a:r>
+              <a:rPr lang="en-US" sz="1100" b="1" spc="250" kern="0" dirty="0">
+                <a:solidFill>
+                  <a:srgbClr val="B04A2F"/>
+                </a:solidFill>
+                <a:latin typeface="Yu Gothic" pitchFamily="34" charset="0"/>
+                <a:ea typeface="Yu Gothic" pitchFamily="34" charset="-122"/>
+                <a:cs typeface="Yu Gothic" pitchFamily="34" charset="-120"/>
+              </a:rPr>
+              <a:t>ここだけは</a:t>
+            </a:r>
+            <a:endParaRPr lang="en-US" sz="1100" dirty="0"/>
+          </a:p>
+        </p:txBody>
+      </p:sp>
+      <p:sp>
+        <p:nvSpPr>
+          <p:cNvPr id="3" name="Text 1"/>
+          <p:cNvSpPr txBox="1"/>
+          <p:nvPr/>
+        </p:nvSpPr>
+        <p:spPr>
+          <a:xfrm>
+            <a:off x="777240" y="1097280"/>
+            <a:ext cx="10607040" cy="640080"/>
+          </a:xfrm>
+          <a:prstGeom prst="rect">
+            <a:avLst/>
+          </a:prstGeom>
+          <a:noFill/>
+          <a:ln/>
+        </p:spPr>
+        <p:txBody>
+          <a:bodyPr wrap="square" lIns="0" tIns="0" rIns="0" bIns="0" rtlCol="0" anchor="ctr"/>
+          <a:lstStyle/>
+          <a:p>
+            <a:pPr indent="0" marL="0">
+              <a:buNone/>
+            </a:pPr>
+            <a:r>
+              <a:rPr lang="en-US" sz="2600" b="1" dirty="0">
+                <a:solidFill>
+                  <a:srgbClr val="23201D"/>
+                </a:solidFill>
+                <a:latin typeface="Yu Gothic" pitchFamily="34" charset="0"/>
+                <a:ea typeface="Yu Gothic" pitchFamily="34" charset="-122"/>
+                <a:cs typeface="Yu Gothic" pitchFamily="34" charset="-120"/>
+              </a:rPr>
+              <a:t>今日は、成果より「手応え」を持ち帰る回です</a:t>
+            </a:r>
+            <a:endParaRPr lang="en-US" sz="2600" dirty="0"/>
+          </a:p>
+        </p:txBody>
+      </p:sp>
+      <p:sp>
+        <p:nvSpPr>
+          <p:cNvPr id="4" name="Shape 2"/>
+          <p:cNvSpPr/>
+          <p:nvPr/>
+        </p:nvSpPr>
+        <p:spPr>
+          <a:xfrm>
+            <a:off x="777240" y="2148840"/>
+            <a:ext cx="64008" cy="2194560"/>
+          </a:xfrm>
+          <a:prstGeom prst="rect">
+            <a:avLst/>
+          </a:prstGeom>
+          <a:solidFill>
+            <a:srgbClr val="B04A2F"/>
+          </a:solidFill>
+          <a:ln w="12700">
+            <a:solidFill>
+              <a:srgbClr val="333333"/>
+            </a:solidFill>
+            <a:prstDash val="solid"/>
+          </a:ln>
+        </p:spPr>
+      </p:sp>
+      <p:sp>
+        <p:nvSpPr>
+          <p:cNvPr id="5" name="Text 3"/>
+          <p:cNvSpPr txBox="1"/>
+          <p:nvPr/>
+        </p:nvSpPr>
+        <p:spPr>
+          <a:xfrm>
+            <a:off x="1188720" y="2148840"/>
+            <a:ext cx="9966960" cy="2194560"/>
+          </a:xfrm>
+          <a:prstGeom prst="rect">
+            <a:avLst/>
+          </a:prstGeom>
+          <a:noFill/>
+          <a:ln/>
+        </p:spPr>
+        <p:txBody>
+          <a:bodyPr wrap="square" lIns="0" tIns="0" rIns="0" bIns="0" rtlCol="0" anchor="ctr"/>
+          <a:lstStyle/>
+          <a:p>
+            <a:pPr indent="0" marL="0">
+              <a:lnSpc>
+                <a:spcPct val="160000"/>
+              </a:lnSpc>
+              <a:buNone/>
+            </a:pPr>
+            <a:r>
+              <a:rPr lang="en-US" sz="1650" dirty="0">
+                <a:solidFill>
+                  <a:srgbClr val="3F3933"/>
+                </a:solidFill>
+                <a:latin typeface="Yu Gothic" pitchFamily="34" charset="0"/>
+                <a:ea typeface="Yu Gothic" pitchFamily="34" charset="-122"/>
+                <a:cs typeface="Yu Gothic" pitchFamily="34" charset="-120"/>
+              </a:rPr>
+              <a:t>診断して終わった初回は、2回目の欠席理由をつくります。だから必ず、その日のうちに1つ動くものを持ち帰っていただきます。小さくて構いません。明日の朝に一度使えるものであることのほうが大事です。</a:t>
+            </a:r>
+            <a:endParaRPr lang="en-US" sz="1650" dirty="0"/>
+          </a:p>
+        </p:txBody>
+      </p:sp>
+      <p:sp>
+        <p:nvSpPr>
+          <p:cNvPr id="6" name="Shape 4"/>
+          <p:cNvSpPr/>
+          <p:nvPr/>
+        </p:nvSpPr>
+        <p:spPr>
+          <a:xfrm>
+            <a:off x="777240" y="4709160"/>
+            <a:ext cx="10607040" cy="960120"/>
+          </a:xfrm>
+          <a:prstGeom prst="rect">
+            <a:avLst/>
+          </a:prstGeom>
+          <a:solidFill>
+            <a:srgbClr val="EDE7DB"/>
+          </a:solidFill>
+          <a:ln w="12700">
+            <a:solidFill>
+              <a:srgbClr val="333333"/>
+            </a:solidFill>
+            <a:prstDash val="solid"/>
+          </a:ln>
+        </p:spPr>
+      </p:sp>
+      <p:sp>
+        <p:nvSpPr>
+          <p:cNvPr id="7" name="Text 5"/>
+          <p:cNvSpPr txBox="1"/>
+          <p:nvPr/>
+        </p:nvSpPr>
+        <p:spPr>
+          <a:xfrm>
+            <a:off x="1051560" y="4800600"/>
+            <a:ext cx="1463040" cy="256032"/>
+          </a:xfrm>
+          <a:prstGeom prst="rect">
+            <a:avLst/>
+          </a:prstGeom>
+          <a:noFill/>
+          <a:ln/>
+        </p:spPr>
+        <p:txBody>
+          <a:bodyPr wrap="square" lIns="0" tIns="0" rIns="0" bIns="0" rtlCol="0" anchor="ctr"/>
+          <a:lstStyle/>
+          <a:p>
+            <a:pPr indent="0" marL="0">
+              <a:buNone/>
+            </a:pPr>
+            <a:r>
+              <a:rPr lang="en-US" sz="900" b="1" spc="150" kern="0" dirty="0">
+                <a:solidFill>
+                  <a:srgbClr val="B04A2F"/>
+                </a:solidFill>
+                <a:latin typeface="Yu Gothic" pitchFamily="34" charset="0"/>
+                <a:ea typeface="Yu Gothic" pitchFamily="34" charset="-122"/>
+                <a:cs typeface="Yu Gothic" pitchFamily="34" charset="-120"/>
+              </a:rPr>
+              <a:t>他社では</a:t>
+            </a:r>
+            <a:endParaRPr lang="en-US" sz="900" dirty="0"/>
+          </a:p>
+        </p:txBody>
+      </p:sp>
+      <p:sp>
+        <p:nvSpPr>
+          <p:cNvPr id="8" name="Text 6"/>
+          <p:cNvSpPr txBox="1"/>
+          <p:nvPr/>
+        </p:nvSpPr>
+        <p:spPr>
+          <a:xfrm>
+            <a:off x="1051560" y="5029200"/>
+            <a:ext cx="10058400" cy="566928"/>
+          </a:xfrm>
+          <a:prstGeom prst="rect">
+            <a:avLst/>
+          </a:prstGeom>
+          <a:noFill/>
+          <a:ln/>
+        </p:spPr>
+        <p:txBody>
+          <a:bodyPr wrap="square" lIns="0" tIns="0" rIns="0" bIns="0" rtlCol="0" anchor="ctr"/>
+          <a:lstStyle/>
+          <a:p>
+            <a:pPr indent="0" marL="0">
+              <a:lnSpc>
+                <a:spcPct val="130000"/>
+              </a:lnSpc>
+              <a:buNone/>
+            </a:pPr>
+            <a:r>
+              <a:rPr lang="en-US" sz="1250" dirty="0">
+                <a:solidFill>
+                  <a:srgbClr val="3F3933"/>
+                </a:solidFill>
+                <a:latin typeface="Yu Gothic" pitchFamily="34" charset="0"/>
+                <a:ea typeface="Yu Gothic" pitchFamily="34" charset="-122"/>
+                <a:cs typeface="Yu Gothic" pitchFamily="34" charset="-120"/>
+              </a:rPr>
+              <a:t>ある会社では、初回に作ったのは「お断りメールの下書き」1本だけでした。ただ、それを翌朝に使ったことで、2回目以降の宿題が一度も止まりませんでした。</a:t>
+            </a:r>
+            <a:endParaRPr lang="en-US" sz="1250" dirty="0"/>
+          </a:p>
+        </p:txBody>
+      </p:sp>
+      <p:sp>
+        <p:nvSpPr>
+          <p:cNvPr id="9" name="Text 7"/>
+          <p:cNvSpPr txBox="1"/>
+          <p:nvPr/>
+        </p:nvSpPr>
+        <p:spPr>
+          <a:xfrm>
+            <a:off x="777240" y="6382512"/>
+            <a:ext cx="7424928" cy="256032"/>
+          </a:xfrm>
+          <a:prstGeom prst="rect">
+            <a:avLst/>
+          </a:prstGeom>
+          <a:noFill/>
+          <a:ln/>
+        </p:spPr>
+        <p:txBody>
+          <a:bodyPr wrap="square" lIns="0" tIns="0" rIns="0" bIns="0" rtlCol="0" anchor="ctr"/>
+          <a:lstStyle/>
+          <a:p>
+            <a:pPr indent="0" marL="0">
+              <a:buNone/>
+            </a:pPr>
+            <a:r>
+              <a:rPr lang="en-US" sz="900" dirty="0">
+                <a:solidFill>
+                  <a:srgbClr val="8A8177"/>
+                </a:solidFill>
+                <a:latin typeface="Yu Gothic" pitchFamily="34" charset="0"/>
+                <a:ea typeface="Yu Gothic" pitchFamily="34" charset="-122"/>
+                <a:cs typeface="Yu Gothic" pitchFamily="34" charset="-120"/>
+              </a:rPr>
+              <a:t>第1回　現状把握と地図づくり</a:t>
+            </a:r>
+            <a:endParaRPr lang="en-US" sz="900" dirty="0"/>
+          </a:p>
+        </p:txBody>
+      </p:sp>
+      <p:sp>
+        <p:nvSpPr>
+          <p:cNvPr id="10" name="Text 8"/>
+          <p:cNvSpPr txBox="1"/>
+          <p:nvPr/>
+        </p:nvSpPr>
+        <p:spPr>
+          <a:xfrm>
+            <a:off x="8202168" y="6382512"/>
+            <a:ext cx="3182112" cy="256032"/>
+          </a:xfrm>
+          <a:prstGeom prst="rect">
+            <a:avLst/>
+          </a:prstGeom>
+          <a:noFill/>
+          <a:ln/>
+        </p:spPr>
+        <p:txBody>
+          <a:bodyPr wrap="square" lIns="0" tIns="0" rIns="0" bIns="0" rtlCol="0" anchor="ctr"/>
+          <a:lstStyle/>
+          <a:p>
+            <a:pPr algn="r" indent="0" marL="0">
+              <a:buNone/>
+            </a:pPr>
+            <a:r>
+              <a:rPr lang="en-US" sz="900" dirty="0">
+                <a:solidFill>
+                  <a:srgbClr val="8A8177"/>
+                </a:solidFill>
+                <a:latin typeface="Yu Gothic" pitchFamily="34" charset="0"/>
+                <a:ea typeface="Yu Gothic" pitchFamily="34" charset="-122"/>
+                <a:cs typeface="Yu Gothic" pitchFamily="34" charset="-120"/>
+              </a:rPr>
+              <a:t>ここだけは</a:t>
+            </a:r>
+            <a:endParaRPr lang="en-US" sz="900" dirty="0"/>
+          </a:p>
+        </p:txBody>
+      </p:sp>
+    </p:spTree>
+  </p:cSld>
+  <p:clrMapOvr>
+    <a:masterClrMapping/>
+  </p:clrMapOvr>
+</p:sld>
+</file>
+
+<file path=ppt/slides/slide14.xml><?xml version="1.0" encoding="utf-8"?>
+<p:sld xmlns:a="http://schemas.openxmlformats.org/drawingml/2006/main" xmlns:r="http://schemas.openxmlformats.org/officeDocument/2006/relationships" xmlns:p="http://schemas.openxmlformats.org/presentationml/2006/main">
+  <p:cSld name="Slide 14">
+    <p:bg>
+      <p:bgPr>
+        <a:solidFill>
+          <a:srgbClr val="F6F2EA"/>
+        </a:solidFill>
+      </p:bgPr>
+    </p:bg>
+    <p:spTree>
+      <p:nvGrpSpPr>
+        <p:cNvPr id="1" name=""/>
+        <p:cNvGrpSpPr/>
+        <p:nvPr/>
+      </p:nvGrpSpPr>
+      <p:grpSpPr>
+        <a:xfrm>
+          <a:off x="0" y="0"/>
+          <a:ext cx="0" cy="0"/>
+          <a:chOff x="0" y="0"/>
+          <a:chExt cx="0" cy="0"/>
+        </a:xfrm>
+      </p:grpSpPr>
+      <p:sp>
+        <p:nvSpPr>
+          <p:cNvPr id="2" name="Text 0"/>
+          <p:cNvSpPr txBox="1"/>
+          <p:nvPr/>
+        </p:nvSpPr>
+        <p:spPr>
+          <a:xfrm>
+            <a:off x="777240" y="566928"/>
+            <a:ext cx="10607040" cy="274320"/>
+          </a:xfrm>
+          <a:prstGeom prst="rect">
+            <a:avLst/>
+          </a:prstGeom>
+          <a:noFill/>
+          <a:ln/>
+        </p:spPr>
+        <p:txBody>
+          <a:bodyPr wrap="square" lIns="0" tIns="0" rIns="0" bIns="0" rtlCol="0" anchor="ctr"/>
+          <a:lstStyle/>
+          <a:p>
+            <a:pPr indent="0" marL="0">
+              <a:buNone/>
+            </a:pPr>
+            <a:r>
+              <a:rPr lang="en-US" sz="1100" b="1" spc="250" kern="0" dirty="0">
+                <a:solidFill>
+                  <a:srgbClr val="3B6B4A"/>
+                </a:solidFill>
+                <a:latin typeface="Yu Gothic" pitchFamily="34" charset="0"/>
+                <a:ea typeface="Yu Gothic" pitchFamily="34" charset="-122"/>
+                <a:cs typeface="Yu Gothic" pitchFamily="34" charset="-120"/>
+              </a:rPr>
+              <a:t>次回まで</a:t>
+            </a:r>
+            <a:endParaRPr lang="en-US" sz="1100" dirty="0"/>
+          </a:p>
+        </p:txBody>
+      </p:sp>
+      <p:sp>
+        <p:nvSpPr>
+          <p:cNvPr id="3" name="Text 1"/>
+          <p:cNvSpPr txBox="1"/>
+          <p:nvPr/>
+        </p:nvSpPr>
+        <p:spPr>
+          <a:xfrm>
+            <a:off x="777240" y="896112"/>
+            <a:ext cx="10607040" cy="640080"/>
+          </a:xfrm>
+          <a:prstGeom prst="rect">
+            <a:avLst/>
+          </a:prstGeom>
+          <a:noFill/>
+          <a:ln/>
+        </p:spPr>
+        <p:txBody>
+          <a:bodyPr wrap="square" lIns="0" tIns="0" rIns="0" bIns="0" rtlCol="0" anchor="ctr"/>
+          <a:lstStyle/>
+          <a:p>
+            <a:pPr indent="0" marL="0">
+              <a:buNone/>
+            </a:pPr>
+            <a:r>
+              <a:rPr lang="en-US" sz="2600" b="1" dirty="0">
+                <a:solidFill>
+                  <a:srgbClr val="23201D"/>
+                </a:solidFill>
+                <a:latin typeface="Yu Gothic" pitchFamily="34" charset="0"/>
+                <a:ea typeface="Yu Gothic" pitchFamily="34" charset="-122"/>
+                <a:cs typeface="Yu Gothic" pitchFamily="34" charset="-120"/>
+              </a:rPr>
+              <a:t>次回は「今のChatGPTの使い方を作り直す」</a:t>
+            </a:r>
+            <a:endParaRPr lang="en-US" sz="2600" dirty="0"/>
+          </a:p>
+        </p:txBody>
+      </p:sp>
+      <p:sp>
+        <p:nvSpPr>
+          <p:cNvPr id="4" name="Text 2"/>
+          <p:cNvSpPr txBox="1"/>
+          <p:nvPr/>
+        </p:nvSpPr>
+        <p:spPr>
+          <a:xfrm>
+            <a:off x="777240" y="1572768"/>
+            <a:ext cx="9546336" cy="457200"/>
+          </a:xfrm>
+          <a:prstGeom prst="rect">
+            <a:avLst/>
+          </a:prstGeom>
+          <a:noFill/>
+          <a:ln/>
+        </p:spPr>
+        <p:txBody>
+          <a:bodyPr wrap="square" lIns="0" tIns="0" rIns="0" bIns="0" rtlCol="0" anchor="ctr"/>
+          <a:lstStyle/>
+          <a:p>
+            <a:pPr indent="0" marL="0">
+              <a:buNone/>
+            </a:pPr>
+            <a:r>
+              <a:rPr lang="en-US" sz="1400" b="1" dirty="0">
+                <a:solidFill>
+                  <a:srgbClr val="3B6B4A"/>
+                </a:solidFill>
+                <a:latin typeface="Yu Gothic" pitchFamily="34" charset="0"/>
+                <a:ea typeface="Yu Gothic" pitchFamily="34" charset="-122"/>
+                <a:cs typeface="Yu Gothic" pitchFamily="34" charset="-120"/>
+              </a:rPr>
+              <a:t>次回は、毎回ゼロから打つのをやめます。たまっていく形に組み替えます。</a:t>
+            </a:r>
+            <a:endParaRPr lang="en-US" sz="1400" dirty="0"/>
+          </a:p>
+        </p:txBody>
+      </p:sp>
+      <p:sp>
+        <p:nvSpPr>
+          <p:cNvPr id="5" name="Shape 3"/>
+          <p:cNvSpPr/>
+          <p:nvPr/>
+        </p:nvSpPr>
+        <p:spPr>
+          <a:xfrm>
+            <a:off x="777240" y="2240280"/>
+            <a:ext cx="4985309" cy="2286000"/>
+          </a:xfrm>
+          <a:prstGeom prst="rect">
+            <a:avLst/>
+          </a:prstGeom>
+          <a:solidFill>
+            <a:srgbClr val="FFFFFF"/>
+          </a:solidFill>
+          <a:ln w="12700">
+            <a:solidFill>
+              <a:srgbClr val="EDE7DB"/>
+            </a:solidFill>
+            <a:prstDash val="solid"/>
+          </a:ln>
+        </p:spPr>
+      </p:sp>
+      <p:sp>
+        <p:nvSpPr>
+          <p:cNvPr id="6" name="Text 4"/>
+          <p:cNvSpPr txBox="1"/>
+          <p:nvPr/>
+        </p:nvSpPr>
+        <p:spPr>
+          <a:xfrm>
+            <a:off x="1051560" y="2377440"/>
+            <a:ext cx="4242816" cy="274320"/>
+          </a:xfrm>
+          <a:prstGeom prst="rect">
+            <a:avLst/>
+          </a:prstGeom>
+          <a:noFill/>
+          <a:ln/>
+        </p:spPr>
+        <p:txBody>
+          <a:bodyPr wrap="square" lIns="0" tIns="0" rIns="0" bIns="0" rtlCol="0" anchor="ctr"/>
+          <a:lstStyle/>
+          <a:p>
+            <a:pPr indent="0" marL="0">
+              <a:buNone/>
+            </a:pPr>
+            <a:r>
+              <a:rPr lang="en-US" sz="1000" b="1" spc="150" kern="0" dirty="0">
+                <a:solidFill>
+                  <a:srgbClr val="B04A2F"/>
+                </a:solidFill>
+                <a:latin typeface="Yu Gothic" pitchFamily="34" charset="0"/>
+                <a:ea typeface="Yu Gothic" pitchFamily="34" charset="-122"/>
+                <a:cs typeface="Yu Gothic" pitchFamily="34" charset="-120"/>
+              </a:rPr>
+              <a:t>次回までにやること</a:t>
+            </a:r>
+            <a:endParaRPr lang="en-US" sz="1000" dirty="0"/>
+          </a:p>
+        </p:txBody>
+      </p:sp>
+      <p:sp>
+        <p:nvSpPr>
+          <p:cNvPr id="7" name="Text 5"/>
+          <p:cNvSpPr txBox="1"/>
+          <p:nvPr/>
+        </p:nvSpPr>
+        <p:spPr>
+          <a:xfrm>
+            <a:off x="1051560" y="2743200"/>
+            <a:ext cx="4436669" cy="1554480"/>
+          </a:xfrm>
+          <a:prstGeom prst="rect">
+            <a:avLst/>
+          </a:prstGeom>
+          <a:noFill/>
+          <a:ln/>
+        </p:spPr>
+        <p:txBody>
+          <a:bodyPr wrap="square" lIns="0" tIns="0" rIns="0" bIns="0" rtlCol="0" anchor="ctr"/>
+          <a:lstStyle/>
+          <a:p>
+            <a:pPr indent="0" marL="0">
+              <a:lnSpc>
+                <a:spcPct val="140000"/>
+              </a:lnSpc>
+              <a:buNone/>
+            </a:pPr>
+            <a:r>
+              <a:rPr lang="en-US" sz="1400" dirty="0">
+                <a:solidFill>
+                  <a:srgbClr val="23201D"/>
+                </a:solidFill>
+                <a:latin typeface="Yu Gothic" pitchFamily="34" charset="0"/>
+                <a:ea typeface="Yu Gothic" pitchFamily="34" charset="-122"/>
+                <a:cs typeface="Yu Gothic" pitchFamily="34" charset="-120"/>
+              </a:rPr>
+              <a:t>明日の朝いちで、今日つくった指示をもう一度使う</a:t>
+            </a:r>
+            <a:endParaRPr lang="en-US" sz="1400" dirty="0"/>
+          </a:p>
+        </p:txBody>
+      </p:sp>
+      <p:sp>
+        <p:nvSpPr>
+          <p:cNvPr id="8" name="Shape 6"/>
+          <p:cNvSpPr/>
+          <p:nvPr/>
+        </p:nvSpPr>
+        <p:spPr>
+          <a:xfrm>
+            <a:off x="6398971" y="2240280"/>
+            <a:ext cx="4985309" cy="2286000"/>
+          </a:xfrm>
+          <a:prstGeom prst="rect">
+            <a:avLst/>
+          </a:prstGeom>
+          <a:solidFill>
+            <a:srgbClr val="FFFFFF"/>
+          </a:solidFill>
+          <a:ln w="12700">
+            <a:solidFill>
+              <a:srgbClr val="EDE7DB"/>
+            </a:solidFill>
+            <a:prstDash val="solid"/>
+          </a:ln>
+        </p:spPr>
+      </p:sp>
+      <p:sp>
+        <p:nvSpPr>
+          <p:cNvPr id="9" name="Text 7"/>
+          <p:cNvSpPr txBox="1"/>
+          <p:nvPr/>
+        </p:nvSpPr>
+        <p:spPr>
+          <a:xfrm>
+            <a:off x="6673291" y="2377440"/>
+            <a:ext cx="4242816" cy="274320"/>
+          </a:xfrm>
+          <a:prstGeom prst="rect">
+            <a:avLst/>
+          </a:prstGeom>
+          <a:noFill/>
+          <a:ln/>
+        </p:spPr>
+        <p:txBody>
+          <a:bodyPr wrap="square" lIns="0" tIns="0" rIns="0" bIns="0" rtlCol="0" anchor="ctr"/>
+          <a:lstStyle/>
+          <a:p>
+            <a:pPr indent="0" marL="0">
+              <a:buNone/>
+            </a:pPr>
+            <a:r>
+              <a:rPr lang="en-US" sz="1000" b="1" spc="150" kern="0" dirty="0">
+                <a:solidFill>
+                  <a:srgbClr val="3B6B4A"/>
+                </a:solidFill>
+                <a:latin typeface="Yu Gothic" pitchFamily="34" charset="0"/>
+                <a:ea typeface="Yu Gothic" pitchFamily="34" charset="-122"/>
+                <a:cs typeface="Yu Gothic" pitchFamily="34" charset="-120"/>
+              </a:rPr>
+              <a:t>次回の持ち物</a:t>
+            </a:r>
+            <a:endParaRPr lang="en-US" sz="1000" dirty="0"/>
+          </a:p>
+        </p:txBody>
+      </p:sp>
+      <p:sp>
+        <p:nvSpPr>
+          <p:cNvPr id="10" name="Text 8"/>
+          <p:cNvSpPr txBox="1"/>
+          <p:nvPr/>
+        </p:nvSpPr>
+        <p:spPr>
+          <a:xfrm>
+            <a:off x="6673291" y="2743200"/>
+            <a:ext cx="4436669" cy="694944"/>
+          </a:xfrm>
+          <a:prstGeom prst="rect">
+            <a:avLst/>
+          </a:prstGeom>
+          <a:noFill/>
+          <a:ln/>
+        </p:spPr>
+        <p:txBody>
+          <a:bodyPr wrap="square" lIns="0" tIns="0" rIns="0" bIns="0" rtlCol="0" anchor="ctr"/>
+          <a:lstStyle/>
+          <a:p>
+            <a:pPr indent="0" marL="0">
+              <a:lnSpc>
+                <a:spcPct val="130000"/>
+              </a:lnSpc>
+              <a:buNone/>
+            </a:pPr>
+            <a:r>
+              <a:rPr lang="en-US" sz="1250" dirty="0">
+                <a:solidFill>
+                  <a:srgbClr val="23201D"/>
+                </a:solidFill>
+                <a:latin typeface="Yu Gothic" pitchFamily="34" charset="0"/>
+                <a:ea typeface="Yu Gothic" pitchFamily="34" charset="-122"/>
+                <a:cs typeface="Yu Gothic" pitchFamily="34" charset="-120"/>
+              </a:rPr>
+              <a:t>・週に3回以上やっている文書業務を1つ決めてくる</a:t>
+            </a:r>
+            <a:endParaRPr lang="en-US" sz="1250" dirty="0"/>
+          </a:p>
+        </p:txBody>
+      </p:sp>
+      <p:sp>
+        <p:nvSpPr>
+          <p:cNvPr id="11" name="Text 9"/>
+          <p:cNvSpPr txBox="1"/>
+          <p:nvPr/>
+        </p:nvSpPr>
+        <p:spPr>
+          <a:xfrm>
+            <a:off x="6673291" y="3474720"/>
+            <a:ext cx="4436669" cy="694944"/>
+          </a:xfrm>
+          <a:prstGeom prst="rect">
+            <a:avLst/>
+          </a:prstGeom>
+          <a:noFill/>
+          <a:ln/>
+        </p:spPr>
+        <p:txBody>
+          <a:bodyPr wrap="square" lIns="0" tIns="0" rIns="0" bIns="0" rtlCol="0" anchor="ctr"/>
+          <a:lstStyle/>
+          <a:p>
+            <a:pPr indent="0" marL="0">
+              <a:lnSpc>
+                <a:spcPct val="130000"/>
+              </a:lnSpc>
+              <a:buNone/>
+            </a:pPr>
+            <a:r>
+              <a:rPr lang="en-US" sz="1250" dirty="0">
+                <a:solidFill>
+                  <a:srgbClr val="23201D"/>
+                </a:solidFill>
+                <a:latin typeface="Yu Gothic" pitchFamily="34" charset="0"/>
+                <a:ea typeface="Yu Gothic" pitchFamily="34" charset="-122"/>
+                <a:cs typeface="Yu Gothic" pitchFamily="34" charset="-120"/>
+              </a:rPr>
+              <a:t>・会社概要の文章（Webサイトのコピーで構いません）</a:t>
+            </a:r>
+            <a:endParaRPr lang="en-US" sz="1250" dirty="0"/>
+          </a:p>
+        </p:txBody>
+      </p:sp>
+      <p:sp>
+        <p:nvSpPr>
+          <p:cNvPr id="12" name="Shape 10"/>
+          <p:cNvSpPr/>
+          <p:nvPr/>
+        </p:nvSpPr>
+        <p:spPr>
+          <a:xfrm>
+            <a:off x="777240" y="4800600"/>
+            <a:ext cx="10607040" cy="777240"/>
+          </a:xfrm>
+          <a:prstGeom prst="rect">
+            <a:avLst/>
+          </a:prstGeom>
+          <a:solidFill>
+            <a:srgbClr val="EDE7DB"/>
+          </a:solidFill>
+          <a:ln w="12700">
+            <a:solidFill>
+              <a:srgbClr val="333333"/>
+            </a:solidFill>
+            <a:prstDash val="solid"/>
+          </a:ln>
+        </p:spPr>
+      </p:sp>
+      <p:sp>
+        <p:nvSpPr>
+          <p:cNvPr id="13" name="Text 11"/>
+          <p:cNvSpPr txBox="1"/>
+          <p:nvPr/>
+        </p:nvSpPr>
+        <p:spPr>
+          <a:xfrm>
+            <a:off x="1097280" y="4800600"/>
+            <a:ext cx="9966960" cy="777240"/>
+          </a:xfrm>
+          <a:prstGeom prst="rect">
+            <a:avLst/>
+          </a:prstGeom>
+          <a:noFill/>
+          <a:ln/>
+        </p:spPr>
+        <p:txBody>
+          <a:bodyPr wrap="square" lIns="0" tIns="0" rIns="0" bIns="0" rtlCol="0" anchor="ctr"/>
+          <a:lstStyle/>
+          <a:p>
+            <a:pPr indent="0" marL="0">
+              <a:buNone/>
+            </a:pPr>
+            <a:r>
+              <a:rPr lang="en-US" sz="1250" dirty="0">
+                <a:solidFill>
+                  <a:srgbClr val="5A534A"/>
+                </a:solidFill>
+                <a:latin typeface="Yu Gothic" pitchFamily="34" charset="0"/>
+                <a:ea typeface="Yu Gothic" pitchFamily="34" charset="-122"/>
+                <a:cs typeface="Yu Gothic" pitchFamily="34" charset="-120"/>
+              </a:rPr>
+              <a:t>この内容は、次回の3日前にあらためてお送りします。</a:t>
+            </a:r>
+            <a:endParaRPr lang="en-US" sz="1250" dirty="0"/>
+          </a:p>
+        </p:txBody>
+      </p:sp>
+      <p:sp>
+        <p:nvSpPr>
+          <p:cNvPr id="14" name="Text 12"/>
+          <p:cNvSpPr txBox="1"/>
+          <p:nvPr/>
+        </p:nvSpPr>
+        <p:spPr>
+          <a:xfrm>
+            <a:off x="777240" y="6382512"/>
+            <a:ext cx="7424928" cy="256032"/>
+          </a:xfrm>
+          <a:prstGeom prst="rect">
+            <a:avLst/>
+          </a:prstGeom>
+          <a:noFill/>
+          <a:ln/>
+        </p:spPr>
+        <p:txBody>
+          <a:bodyPr wrap="square" lIns="0" tIns="0" rIns="0" bIns="0" rtlCol="0" anchor="ctr"/>
+          <a:lstStyle/>
+          <a:p>
+            <a:pPr indent="0" marL="0">
+              <a:buNone/>
+            </a:pPr>
+            <a:r>
+              <a:rPr lang="en-US" sz="900" dirty="0">
+                <a:solidFill>
+                  <a:srgbClr val="8A8177"/>
+                </a:solidFill>
+                <a:latin typeface="Yu Gothic" pitchFamily="34" charset="0"/>
+                <a:ea typeface="Yu Gothic" pitchFamily="34" charset="-122"/>
+                <a:cs typeface="Yu Gothic" pitchFamily="34" charset="-120"/>
+              </a:rPr>
+              <a:t>第1回　現状把握と地図づくり</a:t>
+            </a:r>
+            <a:endParaRPr lang="en-US" sz="900" dirty="0"/>
+          </a:p>
+        </p:txBody>
+      </p:sp>
+      <p:sp>
+        <p:nvSpPr>
+          <p:cNvPr id="15" name="Text 13"/>
+          <p:cNvSpPr txBox="1"/>
+          <p:nvPr/>
+        </p:nvSpPr>
+        <p:spPr>
+          <a:xfrm>
+            <a:off x="8202168" y="6382512"/>
+            <a:ext cx="3182112" cy="256032"/>
+          </a:xfrm>
+          <a:prstGeom prst="rect">
+            <a:avLst/>
+          </a:prstGeom>
+          <a:noFill/>
+          <a:ln/>
+        </p:spPr>
+        <p:txBody>
+          <a:bodyPr wrap="square" lIns="0" tIns="0" rIns="0" bIns="0" rtlCol="0" anchor="ctr"/>
+          <a:lstStyle/>
+          <a:p>
+            <a:pPr algn="r" indent="0" marL="0">
+              <a:buNone/>
+            </a:pPr>
+            <a:r>
+              <a:rPr lang="en-US" sz="900" dirty="0">
+                <a:solidFill>
+                  <a:srgbClr val="8A8177"/>
+                </a:solidFill>
+                <a:latin typeface="Yu Gothic" pitchFamily="34" charset="0"/>
+                <a:ea typeface="Yu Gothic" pitchFamily="34" charset="-122"/>
+                <a:cs typeface="Yu Gothic" pitchFamily="34" charset="-120"/>
+              </a:rPr>
+              <a:t>次回まで</a:t>
+            </a:r>
+            <a:endParaRPr lang="en-US" sz="900" dirty="0"/>
+          </a:p>
+        </p:txBody>
+      </p:sp>
+    </p:spTree>
+  </p:cSld>
+  <p:clrMapOvr>
+    <a:masterClrMapping/>
+  </p:clrMapOvr>
+</p:sld>
+</file>
+
+<file path=ppt/slides/slide15.xml><?xml version="1.0" encoding="utf-8"?>
+<p:sld xmlns:a="http://schemas.openxmlformats.org/drawingml/2006/main" xmlns:r="http://schemas.openxmlformats.org/officeDocument/2006/relationships" xmlns:p="http://schemas.openxmlformats.org/presentationml/2006/main">
+  <p:cSld name="Slide 15">
     <p:bg>
       <p:bgPr>
         <a:solidFill>
@@ -8388,13 +10566,13 @@
             <a:r>
               <a:rPr lang="en-US" sz="1100" b="1" spc="250" kern="0" dirty="0">
                 <a:solidFill>
-                  <a:srgbClr val="2F4F6B"/>
-                </a:solidFill>
-                <a:latin typeface="Yu Gothic" pitchFamily="34" charset="0"/>
-                <a:ea typeface="Yu Gothic" pitchFamily="34" charset="-122"/>
-                <a:cs typeface="Yu Gothic" pitchFamily="34" charset="-120"/>
-              </a:rPr>
-              <a:t>演習</a:t>
+                  <a:srgbClr val="B04A2F"/>
+                </a:solidFill>
+                <a:latin typeface="Yu Gothic" pitchFamily="34" charset="0"/>
+                <a:ea typeface="Yu Gothic" pitchFamily="34" charset="-122"/>
+                <a:cs typeface="Yu Gothic" pitchFamily="34" charset="-120"/>
+              </a:rPr>
+              <a:t>想定問答</a:t>
             </a:r>
             <a:endParaRPr lang="en-US" sz="1100" dirty="0"/>
           </a:p>
@@ -8433,7 +10611,7 @@
                 <a:ea typeface="Yu Gothic" pitchFamily="34" charset="-122"/>
                 <a:cs typeface="Yu Gothic" pitchFamily="34" charset="-120"/>
               </a:rPr>
-              <a:t>今日、一緒にやること</a:t>
+              <a:t>この回で、よく聞かれること</a:t>
             </a:r>
             <a:endParaRPr lang="en-US" sz="2600" dirty="0"/>
           </a:p>
@@ -8441,53 +10619,14 @@
       </p:sp>
       <p:sp>
         <p:nvSpPr>
-          <p:cNvPr id="4" name="Text 2"/>
-          <p:cNvSpPr txBox="1"/>
-          <p:nvPr/>
-        </p:nvSpPr>
-        <p:spPr>
-          <a:xfrm>
-            <a:off x="777240" y="1572768"/>
-            <a:ext cx="10607040" cy="320040"/>
-          </a:xfrm>
-          <a:prstGeom prst="rect">
-            <a:avLst/>
-          </a:prstGeom>
-          <a:noFill/>
-          <a:ln/>
-        </p:spPr>
-        <p:txBody>
-          <a:bodyPr wrap="square" lIns="0" tIns="0" rIns="0" bIns="0" rtlCol="0" anchor="ctr"/>
-          <a:lstStyle/>
-          <a:p>
-            <a:pPr indent="0" marL="0">
-              <a:buNone/>
-            </a:pPr>
-            <a:r>
-              <a:rPr lang="en-US" sz="1250" b="1" dirty="0">
-                <a:solidFill>
-                  <a:srgbClr val="2F4F6B"/>
-                </a:solidFill>
-                <a:latin typeface="Yu Gothic" pitchFamily="34" charset="0"/>
-                <a:ea typeface="Yu Gothic" pitchFamily="34" charset="-122"/>
-                <a:cs typeface="Yu Gothic" pitchFamily="34" charset="-120"/>
-              </a:rPr>
-              <a:t>55分。操作するのはご自身です。</a:t>
-            </a:r>
-            <a:endParaRPr lang="en-US" sz="1250" dirty="0"/>
-          </a:p>
-        </p:txBody>
-      </p:sp>
-      <p:sp>
-        <p:nvSpPr>
-          <p:cNvPr id="5" name="Shape 3"/>
+          <p:cNvPr id="4" name="Shape 2"/>
           <p:cNvSpPr/>
           <p:nvPr/>
         </p:nvSpPr>
         <p:spPr>
           <a:xfrm>
-            <a:off x="777240" y="2148840"/>
-            <a:ext cx="3383280" cy="2880360"/>
+            <a:off x="777240" y="1737360"/>
+            <a:ext cx="10607040" cy="1170432"/>
           </a:xfrm>
           <a:prstGeom prst="rect">
             <a:avLst/>
@@ -8505,16 +10644,16 @@
       </p:sp>
       <p:sp>
         <p:nvSpPr>
-          <p:cNvPr id="6" name="Shape 4"/>
+          <p:cNvPr id="5" name="Shape 3"/>
           <p:cNvSpPr/>
           <p:nvPr/>
         </p:nvSpPr>
         <p:spPr>
           <a:xfrm>
-            <a:off x="1051560" y="2395728"/>
-            <a:ext cx="438912" cy="438912"/>
-          </a:xfrm>
-          <a:prstGeom prst="ellipse">
+            <a:off x="777240" y="1737360"/>
+            <a:ext cx="54864" cy="1170432"/>
+          </a:xfrm>
+          <a:prstGeom prst="rect">
             <a:avLst/>
           </a:prstGeom>
           <a:solidFill>
@@ -8530,95 +10669,53 @@
       </p:sp>
       <p:sp>
         <p:nvSpPr>
+          <p:cNvPr id="6" name="Text 4"/>
+          <p:cNvSpPr txBox="1"/>
+          <p:nvPr/>
+        </p:nvSpPr>
+        <p:spPr>
+          <a:xfrm>
+            <a:off x="1097280" y="1828800"/>
+            <a:ext cx="9966960" cy="384048"/>
+          </a:xfrm>
+          <a:prstGeom prst="rect">
+            <a:avLst/>
+          </a:prstGeom>
+          <a:noFill/>
+          <a:ln/>
+        </p:spPr>
+        <p:txBody>
+          <a:bodyPr wrap="square" lIns="0" tIns="0" rIns="0" bIns="0" rtlCol="0" anchor="ctr"/>
+          <a:lstStyle/>
+          <a:p>
+            <a:pPr indent="0" marL="0">
+              <a:buNone/>
+            </a:pPr>
+            <a:r>
+              <a:rPr lang="en-US" sz="1400" b="1" dirty="0">
+                <a:solidFill>
+                  <a:srgbClr val="2F4F6B"/>
+                </a:solidFill>
+                <a:latin typeface="Yu Gothic" pitchFamily="34" charset="0"/>
+                <a:ea typeface="Yu Gothic" pitchFamily="34" charset="-122"/>
+                <a:cs typeface="Yu Gothic" pitchFamily="34" charset="-120"/>
+              </a:rPr>
+              <a:t>「うちの業界は特殊なので、使えないのでは」</a:t>
+            </a:r>
+            <a:endParaRPr lang="en-US" sz="1400" dirty="0"/>
+          </a:p>
+        </p:txBody>
+      </p:sp>
+      <p:sp>
+        <p:nvSpPr>
           <p:cNvPr id="7" name="Text 5"/>
           <p:cNvSpPr txBox="1"/>
           <p:nvPr/>
         </p:nvSpPr>
         <p:spPr>
           <a:xfrm>
-            <a:off x="1051560" y="2395728"/>
-            <a:ext cx="438912" cy="438912"/>
-          </a:xfrm>
-          <a:prstGeom prst="rect">
-            <a:avLst/>
-          </a:prstGeom>
-          <a:noFill/>
-          <a:ln/>
-        </p:spPr>
-        <p:txBody>
-          <a:bodyPr wrap="square" lIns="0" tIns="0" rIns="0" bIns="0" rtlCol="0" anchor="ctr"/>
-          <a:lstStyle/>
-          <a:p>
-            <a:pPr algn="ctr" indent="0" marL="0">
-              <a:buNone/>
-            </a:pPr>
-            <a:r>
-              <a:rPr lang="en-US" sz="1300" b="1" dirty="0">
-                <a:solidFill>
-                  <a:srgbClr val="FFFFFF"/>
-                </a:solidFill>
-                <a:latin typeface="Yu Gothic" pitchFamily="34" charset="0"/>
-                <a:ea typeface="Yu Gothic" pitchFamily="34" charset="-122"/>
-                <a:cs typeface="Yu Gothic" pitchFamily="34" charset="-120"/>
-              </a:rPr>
-              <a:t>1</a:t>
-            </a:r>
-            <a:endParaRPr lang="en-US" sz="1300" dirty="0"/>
-          </a:p>
-        </p:txBody>
-      </p:sp>
-      <p:sp>
-        <p:nvSpPr>
-          <p:cNvPr id="8" name="Text 6"/>
-          <p:cNvSpPr txBox="1"/>
-          <p:nvPr/>
-        </p:nvSpPr>
-        <p:spPr>
-          <a:xfrm>
-            <a:off x="1051560" y="2944368"/>
-            <a:ext cx="2834640" cy="731520"/>
-          </a:xfrm>
-          <a:prstGeom prst="rect">
-            <a:avLst/>
-          </a:prstGeom>
-          <a:noFill/>
-          <a:ln/>
-        </p:spPr>
-        <p:txBody>
-          <a:bodyPr wrap="square" lIns="0" tIns="0" rIns="0" bIns="0" rtlCol="0" anchor="ctr"/>
-          <a:lstStyle/>
-          <a:p>
-            <a:pPr indent="0" marL="0">
-              <a:lnSpc>
-                <a:spcPct val="125000"/>
-              </a:lnSpc>
-              <a:buNone/>
-            </a:pPr>
-            <a:r>
-              <a:rPr lang="en-US" sz="1450" b="1" dirty="0">
-                <a:solidFill>
-                  <a:srgbClr val="23201D"/>
-                </a:solidFill>
-                <a:latin typeface="Yu Gothic" pitchFamily="34" charset="0"/>
-                <a:ea typeface="Yu Gothic" pitchFamily="34" charset="-122"/>
-                <a:cs typeface="Yu Gothic" pitchFamily="34" charset="-120"/>
-              </a:rPr>
-              <a:t>いまの使い方を拝見する</a:t>
-            </a:r>
-            <a:endParaRPr lang="en-US" sz="1450" dirty="0"/>
-          </a:p>
-        </p:txBody>
-      </p:sp>
-      <p:sp>
-        <p:nvSpPr>
-          <p:cNvPr id="9" name="Text 7"/>
-          <p:cNvSpPr txBox="1"/>
-          <p:nvPr/>
-        </p:nvSpPr>
-        <p:spPr>
-          <a:xfrm>
-            <a:off x="1051560" y="3703320"/>
-            <a:ext cx="2834640" cy="1188720"/>
+            <a:off x="1097280" y="2231136"/>
+            <a:ext cx="9966960" cy="603504"/>
           </a:xfrm>
           <a:prstGeom prst="rect">
             <a:avLst/>
@@ -8637,30 +10734,30 @@
               <a:buNone/>
             </a:pPr>
             <a:r>
-              <a:rPr lang="en-US" sz="1150" dirty="0">
-                <a:solidFill>
-                  <a:srgbClr val="5A534A"/>
-                </a:solidFill>
-                <a:latin typeface="Yu Gothic" pitchFamily="34" charset="0"/>
-                <a:ea typeface="Yu Gothic" pitchFamily="34" charset="-122"/>
-                <a:cs typeface="Yu Gothic" pitchFamily="34" charset="-120"/>
-              </a:rPr>
-              <a:t>20分。普段どおりに操作していただきます。うまくやろうとしなくて大丈夫です</a:t>
-            </a:r>
-            <a:endParaRPr lang="en-US" sz="1150" dirty="0"/>
-          </a:p>
-        </p:txBody>
-      </p:sp>
-      <p:sp>
-        <p:nvSpPr>
-          <p:cNvPr id="10" name="Shape 8"/>
+              <a:rPr lang="en-US" sz="1250" dirty="0">
+                <a:solidFill>
+                  <a:srgbClr val="3F3933"/>
+                </a:solidFill>
+                <a:latin typeface="Yu Gothic" pitchFamily="34" charset="0"/>
+                <a:ea typeface="Yu Gothic" pitchFamily="34" charset="-122"/>
+                <a:cs typeface="Yu Gothic" pitchFamily="34" charset="-120"/>
+              </a:rPr>
+              <a:t>特殊なのは判断の部分で、その周りの定型業務はどの業界も驚くほど似ています。棚卸し表で、どこが特殊でどこが共通かを分けて見せます。</a:t>
+            </a:r>
+            <a:endParaRPr lang="en-US" sz="1250" dirty="0"/>
+          </a:p>
+        </p:txBody>
+      </p:sp>
+      <p:sp>
+        <p:nvSpPr>
+          <p:cNvPr id="8" name="Shape 6"/>
           <p:cNvSpPr/>
           <p:nvPr/>
         </p:nvSpPr>
         <p:spPr>
           <a:xfrm>
-            <a:off x="4389120" y="2148840"/>
-            <a:ext cx="3383280" cy="2880360"/>
+            <a:off x="777240" y="3035808"/>
+            <a:ext cx="10607040" cy="1170432"/>
           </a:xfrm>
           <a:prstGeom prst="rect">
             <a:avLst/>
@@ -8678,16 +10775,16 @@
       </p:sp>
       <p:sp>
         <p:nvSpPr>
-          <p:cNvPr id="11" name="Shape 9"/>
+          <p:cNvPr id="9" name="Shape 7"/>
           <p:cNvSpPr/>
           <p:nvPr/>
         </p:nvSpPr>
         <p:spPr>
           <a:xfrm>
-            <a:off x="4663440" y="2395728"/>
-            <a:ext cx="438912" cy="438912"/>
-          </a:xfrm>
-          <a:prstGeom prst="ellipse">
+            <a:off x="777240" y="3035808"/>
+            <a:ext cx="54864" cy="1170432"/>
+          </a:xfrm>
+          <a:prstGeom prst="rect">
             <a:avLst/>
           </a:prstGeom>
           <a:solidFill>
@@ -8703,95 +10800,53 @@
       </p:sp>
       <p:sp>
         <p:nvSpPr>
-          <p:cNvPr id="12" name="Text 10"/>
-          <p:cNvSpPr txBox="1"/>
-          <p:nvPr/>
-        </p:nvSpPr>
-        <p:spPr>
-          <a:xfrm>
-            <a:off x="4663440" y="2395728"/>
-            <a:ext cx="438912" cy="438912"/>
-          </a:xfrm>
-          <a:prstGeom prst="rect">
-            <a:avLst/>
-          </a:prstGeom>
-          <a:noFill/>
-          <a:ln/>
-        </p:spPr>
-        <p:txBody>
-          <a:bodyPr wrap="square" lIns="0" tIns="0" rIns="0" bIns="0" rtlCol="0" anchor="ctr"/>
-          <a:lstStyle/>
-          <a:p>
-            <a:pPr algn="ctr" indent="0" marL="0">
-              <a:buNone/>
-            </a:pPr>
-            <a:r>
-              <a:rPr lang="en-US" sz="1300" b="1" dirty="0">
-                <a:solidFill>
-                  <a:srgbClr val="FFFFFF"/>
-                </a:solidFill>
-                <a:latin typeface="Yu Gothic" pitchFamily="34" charset="0"/>
-                <a:ea typeface="Yu Gothic" pitchFamily="34" charset="-122"/>
-                <a:cs typeface="Yu Gothic" pitchFamily="34" charset="-120"/>
-              </a:rPr>
-              <a:t>2</a:t>
-            </a:r>
-            <a:endParaRPr lang="en-US" sz="1300" dirty="0"/>
-          </a:p>
-        </p:txBody>
-      </p:sp>
-      <p:sp>
-        <p:nvSpPr>
-          <p:cNvPr id="13" name="Text 11"/>
-          <p:cNvSpPr txBox="1"/>
-          <p:nvPr/>
-        </p:nvSpPr>
-        <p:spPr>
-          <a:xfrm>
-            <a:off x="4663440" y="2944368"/>
-            <a:ext cx="2834640" cy="731520"/>
-          </a:xfrm>
-          <a:prstGeom prst="rect">
-            <a:avLst/>
-          </a:prstGeom>
-          <a:noFill/>
-          <a:ln/>
-        </p:spPr>
-        <p:txBody>
-          <a:bodyPr wrap="square" lIns="0" tIns="0" rIns="0" bIns="0" rtlCol="0" anchor="ctr"/>
-          <a:lstStyle/>
-          <a:p>
-            <a:pPr indent="0" marL="0">
-              <a:lnSpc>
-                <a:spcPct val="125000"/>
-              </a:lnSpc>
-              <a:buNone/>
-            </a:pPr>
-            <a:r>
-              <a:rPr lang="en-US" sz="1450" b="1" dirty="0">
-                <a:solidFill>
-                  <a:srgbClr val="23201D"/>
-                </a:solidFill>
-                <a:latin typeface="Yu Gothic" pitchFamily="34" charset="0"/>
-                <a:ea typeface="Yu Gothic" pitchFamily="34" charset="-122"/>
-                <a:cs typeface="Yu Gothic" pitchFamily="34" charset="-120"/>
-              </a:rPr>
-              <a:t>業務を棚卸しする</a:t>
-            </a:r>
-            <a:endParaRPr lang="en-US" sz="1450" dirty="0"/>
-          </a:p>
-        </p:txBody>
-      </p:sp>
-      <p:sp>
-        <p:nvSpPr>
-          <p:cNvPr id="14" name="Text 12"/>
-          <p:cNvSpPr txBox="1"/>
-          <p:nvPr/>
-        </p:nvSpPr>
-        <p:spPr>
-          <a:xfrm>
-            <a:off x="4663440" y="3703320"/>
-            <a:ext cx="2834640" cy="1188720"/>
+          <p:cNvPr id="10" name="Text 8"/>
+          <p:cNvSpPr txBox="1"/>
+          <p:nvPr/>
+        </p:nvSpPr>
+        <p:spPr>
+          <a:xfrm>
+            <a:off x="1097280" y="3127248"/>
+            <a:ext cx="9966960" cy="384048"/>
+          </a:xfrm>
+          <a:prstGeom prst="rect">
+            <a:avLst/>
+          </a:prstGeom>
+          <a:noFill/>
+          <a:ln/>
+        </p:spPr>
+        <p:txBody>
+          <a:bodyPr wrap="square" lIns="0" tIns="0" rIns="0" bIns="0" rtlCol="0" anchor="ctr"/>
+          <a:lstStyle/>
+          <a:p>
+            <a:pPr indent="0" marL="0">
+              <a:buNone/>
+            </a:pPr>
+            <a:r>
+              <a:rPr lang="en-US" sz="1400" b="1" dirty="0">
+                <a:solidFill>
+                  <a:srgbClr val="2F4F6B"/>
+                </a:solidFill>
+                <a:latin typeface="Yu Gothic" pitchFamily="34" charset="0"/>
+                <a:ea typeface="Yu Gothic" pitchFamily="34" charset="-122"/>
+                <a:cs typeface="Yu Gothic" pitchFamily="34" charset="-120"/>
+              </a:rPr>
+              <a:t>「社員にやらせたほうが早いのでは」</a:t>
+            </a:r>
+            <a:endParaRPr lang="en-US" sz="1400" dirty="0"/>
+          </a:p>
+        </p:txBody>
+      </p:sp>
+      <p:sp>
+        <p:nvSpPr>
+          <p:cNvPr id="11" name="Text 9"/>
+          <p:cNvSpPr txBox="1"/>
+          <p:nvPr/>
+        </p:nvSpPr>
+        <p:spPr>
+          <a:xfrm>
+            <a:off x="1097280" y="3529584"/>
+            <a:ext cx="9966960" cy="603504"/>
           </a:xfrm>
           <a:prstGeom prst="rect">
             <a:avLst/>
@@ -8810,30 +10865,30 @@
               <a:buNone/>
             </a:pPr>
             <a:r>
-              <a:rPr lang="en-US" sz="1150" dirty="0">
-                <a:solidFill>
-                  <a:srgbClr val="5A534A"/>
-                </a:solidFill>
-                <a:latin typeface="Yu Gothic" pitchFamily="34" charset="0"/>
-                <a:ea typeface="Yu Gothic" pitchFamily="34" charset="-122"/>
-                <a:cs typeface="Yu Gothic" pitchFamily="34" charset="-120"/>
-              </a:rPr>
-              <a:t>実際の一週間を聞きながら、6列の表をその場で埋めます</a:t>
-            </a:r>
-            <a:endParaRPr lang="en-US" sz="1150" dirty="0"/>
-          </a:p>
-        </p:txBody>
-      </p:sp>
-      <p:sp>
-        <p:nvSpPr>
-          <p:cNvPr id="15" name="Shape 13"/>
+              <a:rPr lang="en-US" sz="1250" dirty="0">
+                <a:solidFill>
+                  <a:srgbClr val="3F3933"/>
+                </a:solidFill>
+                <a:latin typeface="Yu Gothic" pitchFamily="34" charset="0"/>
+                <a:ea typeface="Yu Gothic" pitchFamily="34" charset="-122"/>
+                <a:cs typeface="Yu Gothic" pitchFamily="34" charset="-120"/>
+              </a:rPr>
+              <a:t>第5回までは社長ご自身に使っていただきます。判断の勘所は、使った人にしか分かりません。社員に渡すのは第3回から、1名ずつです。</a:t>
+            </a:r>
+            <a:endParaRPr lang="en-US" sz="1250" dirty="0"/>
+          </a:p>
+        </p:txBody>
+      </p:sp>
+      <p:sp>
+        <p:nvSpPr>
+          <p:cNvPr id="12" name="Shape 10"/>
           <p:cNvSpPr/>
           <p:nvPr/>
         </p:nvSpPr>
         <p:spPr>
           <a:xfrm>
-            <a:off x="8001000" y="2148840"/>
-            <a:ext cx="3383280" cy="2880360"/>
+            <a:off x="777240" y="4334256"/>
+            <a:ext cx="10607040" cy="1170432"/>
           </a:xfrm>
           <a:prstGeom prst="rect">
             <a:avLst/>
@@ -8851,16 +10906,16 @@
       </p:sp>
       <p:sp>
         <p:nvSpPr>
-          <p:cNvPr id="16" name="Shape 14"/>
+          <p:cNvPr id="13" name="Shape 11"/>
           <p:cNvSpPr/>
           <p:nvPr/>
         </p:nvSpPr>
         <p:spPr>
           <a:xfrm>
-            <a:off x="8275320" y="2395728"/>
-            <a:ext cx="438912" cy="438912"/>
-          </a:xfrm>
-          <a:prstGeom prst="ellipse">
+            <a:off x="777240" y="4334256"/>
+            <a:ext cx="54864" cy="1170432"/>
+          </a:xfrm>
+          <a:prstGeom prst="rect">
             <a:avLst/>
           </a:prstGeom>
           <a:solidFill>
@@ -8876,95 +10931,53 @@
       </p:sp>
       <p:sp>
         <p:nvSpPr>
-          <p:cNvPr id="17" name="Text 15"/>
-          <p:cNvSpPr txBox="1"/>
-          <p:nvPr/>
-        </p:nvSpPr>
-        <p:spPr>
-          <a:xfrm>
-            <a:off x="8275320" y="2395728"/>
-            <a:ext cx="438912" cy="438912"/>
-          </a:xfrm>
-          <a:prstGeom prst="rect">
-            <a:avLst/>
-          </a:prstGeom>
-          <a:noFill/>
-          <a:ln/>
-        </p:spPr>
-        <p:txBody>
-          <a:bodyPr wrap="square" lIns="0" tIns="0" rIns="0" bIns="0" rtlCol="0" anchor="ctr"/>
-          <a:lstStyle/>
-          <a:p>
-            <a:pPr algn="ctr" indent="0" marL="0">
-              <a:buNone/>
-            </a:pPr>
-            <a:r>
-              <a:rPr lang="en-US" sz="1300" b="1" dirty="0">
-                <a:solidFill>
-                  <a:srgbClr val="FFFFFF"/>
-                </a:solidFill>
-                <a:latin typeface="Yu Gothic" pitchFamily="34" charset="0"/>
-                <a:ea typeface="Yu Gothic" pitchFamily="34" charset="-122"/>
-                <a:cs typeface="Yu Gothic" pitchFamily="34" charset="-120"/>
-              </a:rPr>
-              <a:t>3</a:t>
-            </a:r>
-            <a:endParaRPr lang="en-US" sz="1300" dirty="0"/>
-          </a:p>
-        </p:txBody>
-      </p:sp>
-      <p:sp>
-        <p:nvSpPr>
-          <p:cNvPr id="18" name="Text 16"/>
-          <p:cNvSpPr txBox="1"/>
-          <p:nvPr/>
-        </p:nvSpPr>
-        <p:spPr>
-          <a:xfrm>
-            <a:off x="8275320" y="2944368"/>
-            <a:ext cx="2834640" cy="731520"/>
-          </a:xfrm>
-          <a:prstGeom prst="rect">
-            <a:avLst/>
-          </a:prstGeom>
-          <a:noFill/>
-          <a:ln/>
-        </p:spPr>
-        <p:txBody>
-          <a:bodyPr wrap="square" lIns="0" tIns="0" rIns="0" bIns="0" rtlCol="0" anchor="ctr"/>
-          <a:lstStyle/>
-          <a:p>
-            <a:pPr indent="0" marL="0">
-              <a:lnSpc>
-                <a:spcPct val="125000"/>
-              </a:lnSpc>
-              <a:buNone/>
-            </a:pPr>
-            <a:r>
-              <a:rPr lang="en-US" sz="1450" b="1" dirty="0">
-                <a:solidFill>
-                  <a:srgbClr val="23201D"/>
-                </a:solidFill>
-                <a:latin typeface="Yu Gothic" pitchFamily="34" charset="0"/>
-                <a:ea typeface="Yu Gothic" pitchFamily="34" charset="-122"/>
-                <a:cs typeface="Yu Gothic" pitchFamily="34" charset="-120"/>
-              </a:rPr>
-              <a:t>1つ、その場で解かせる</a:t>
-            </a:r>
-            <a:endParaRPr lang="en-US" sz="1450" dirty="0"/>
-          </a:p>
-        </p:txBody>
-      </p:sp>
-      <p:sp>
-        <p:nvSpPr>
-          <p:cNvPr id="19" name="Text 17"/>
-          <p:cNvSpPr txBox="1"/>
-          <p:nvPr/>
-        </p:nvSpPr>
-        <p:spPr>
-          <a:xfrm>
-            <a:off x="8275320" y="3703320"/>
-            <a:ext cx="2834640" cy="1188720"/>
+          <p:cNvPr id="14" name="Text 12"/>
+          <p:cNvSpPr txBox="1"/>
+          <p:nvPr/>
+        </p:nvSpPr>
+        <p:spPr>
+          <a:xfrm>
+            <a:off x="1097280" y="4425696"/>
+            <a:ext cx="9966960" cy="384048"/>
+          </a:xfrm>
+          <a:prstGeom prst="rect">
+            <a:avLst/>
+          </a:prstGeom>
+          <a:noFill/>
+          <a:ln/>
+        </p:spPr>
+        <p:txBody>
+          <a:bodyPr wrap="square" lIns="0" tIns="0" rIns="0" bIns="0" rtlCol="0" anchor="ctr"/>
+          <a:lstStyle/>
+          <a:p>
+            <a:pPr indent="0" marL="0">
+              <a:buNone/>
+            </a:pPr>
+            <a:r>
+              <a:rPr lang="en-US" sz="1400" b="1" dirty="0">
+                <a:solidFill>
+                  <a:srgbClr val="2F4F6B"/>
+                </a:solidFill>
+                <a:latin typeface="Yu Gothic" pitchFamily="34" charset="0"/>
+                <a:ea typeface="Yu Gothic" pitchFamily="34" charset="-122"/>
+                <a:cs typeface="Yu Gothic" pitchFamily="34" charset="-120"/>
+              </a:rPr>
+              <a:t>「無料のままで足りますか」</a:t>
+            </a:r>
+            <a:endParaRPr lang="en-US" sz="1400" dirty="0"/>
+          </a:p>
+        </p:txBody>
+      </p:sp>
+      <p:sp>
+        <p:nvSpPr>
+          <p:cNvPr id="15" name="Text 13"/>
+          <p:cNvSpPr txBox="1"/>
+          <p:nvPr/>
+        </p:nvSpPr>
+        <p:spPr>
+          <a:xfrm>
+            <a:off x="1097280" y="4828032"/>
+            <a:ext cx="9966960" cy="603504"/>
           </a:xfrm>
           <a:prstGeom prst="rect">
             <a:avLst/>
@@ -8983,23 +10996,23 @@
               <a:buNone/>
             </a:pPr>
             <a:r>
-              <a:rPr lang="en-US" sz="1150" dirty="0">
-                <a:solidFill>
-                  <a:srgbClr val="5A534A"/>
-                </a:solidFill>
-                <a:latin typeface="Yu Gothic" pitchFamily="34" charset="0"/>
-                <a:ea typeface="Yu Gothic" pitchFamily="34" charset="-122"/>
-                <a:cs typeface="Yu Gothic" pitchFamily="34" charset="-120"/>
-              </a:rPr>
-              <a:t>上位3つのうち1つを今日のうちに動かし、指示文を保存して持ち帰ります</a:t>
-            </a:r>
-            <a:endParaRPr lang="en-US" sz="1150" dirty="0"/>
-          </a:p>
-        </p:txBody>
-      </p:sp>
-      <p:sp>
-        <p:nvSpPr>
-          <p:cNvPr id="20" name="Text 18"/>
+              <a:rPr lang="en-US" sz="1250" dirty="0">
+                <a:solidFill>
+                  <a:srgbClr val="3F3933"/>
+                </a:solidFill>
+                <a:latin typeface="Yu Gothic" pitchFamily="34" charset="0"/>
+                <a:ea typeface="Yu Gothic" pitchFamily="34" charset="-122"/>
+                <a:cs typeface="Yu Gothic" pitchFamily="34" charset="-120"/>
+              </a:rPr>
+              <a:t>第4回まではほぼ足ります。第5回以降の演習で機能差が出ますが、そのときに必要な機能と金額をお示しします。契約はご判断にお任せします。</a:t>
+            </a:r>
+            <a:endParaRPr lang="en-US" sz="1250" dirty="0"/>
+          </a:p>
+        </p:txBody>
+      </p:sp>
+      <p:sp>
+        <p:nvSpPr>
+          <p:cNvPr id="16" name="Text 14"/>
           <p:cNvSpPr txBox="1"/>
           <p:nvPr/>
         </p:nvSpPr>
@@ -9038,7 +11051,7 @@
       </p:sp>
       <p:sp>
         <p:nvSpPr>
-          <p:cNvPr id="21" name="Text 19"/>
+          <p:cNvPr id="17" name="Text 15"/>
           <p:cNvSpPr txBox="1"/>
           <p:nvPr/>
         </p:nvSpPr>
@@ -9069,7 +11082,7 @@
                 <a:ea typeface="Yu Gothic" pitchFamily="34" charset="-122"/>
                 <a:cs typeface="Yu Gothic" pitchFamily="34" charset="-120"/>
               </a:rPr>
-              <a:t>演習</a:t>
+              <a:t>想定問答</a:t>
             </a:r>
             <a:endParaRPr lang="en-US" sz="900" dirty="0"/>
           </a:p>

</xml_diff>